<commit_message>
Configure LPU HRDC Nexus training lifecycle platform, adding LangGraph pipelines, PWA manifests, and geofenced attendance
</commit_message>
<xml_diff>
--- a/LPU_FDP_Presentation.pptx
+++ b/LPU_FDP_Presentation.pptx
@@ -22,6 +22,7 @@
     <p:sldId id="270" r:id="rId22"/>
     <p:sldId id="271" r:id="rId23"/>
     <p:sldId id="272" r:id="rId24"/>
+    <p:sldId id="273" r:id="rId25"/>
   </p:sldIdLst>
   <p:sldSz cx="9144000" cy="6858000" type="screen4x3"/>
   <p:notesSz cx="6858000" cy="9144000"/>
@@ -518,7 +519,7 @@
           <a:lstStyle/>
           <a:p>
             <a:r>
-              <a:t>Good morning members of the FDP evaluation panel. Today, we present the LPU Academic Copilot, a full-stack platform driven by a 10-agent orchestrator to automate the standard curriculum preparation workflow.</a:t>
+              <a:t>Good morning members of the HRDC leadership panel. Today, we present LPU HRDC Nexus, an enterprise-grade AI-powered training lifecycle management platform designed to automate and digitize the complete training program pipeline.</a:t>
             </a:r>
           </a:p>
         </p:txBody>
@@ -588,7 +589,7 @@
           <a:lstStyle/>
           <a:p>
             <a:r>
-              <a:t>The database contains six main relational tables. The agent logs feed our front-end progress indicators, providing trace information to users in real-time.</a:t>
+              <a:t>Auto-grading saves faculty extensive evaluation time. The leaderboard fosters a healthy learning dynamic.</a:t>
             </a:r>
           </a:p>
         </p:txBody>
@@ -658,7 +659,7 @@
           <a:lstStyle/>
           <a:p>
             <a:r>
-              <a:t>The key features include progress tracking, configuration customization, and automatic database fallbacks, rendering the platform robust.</a:t>
+              <a:t>Nexus evaluates training return-on-investment (ROI) by assessing pre-post test score differences.</a:t>
             </a:r>
           </a:p>
         </p:txBody>
@@ -728,7 +729,7 @@
           <a:lstStyle/>
           <a:p>
             <a:r>
-              <a:t>For the evaluation, we demonstrate a complete flow using a sample Machine Learning syllabus. We register, upload, watch the log timeline, and download the output PDF.</a:t>
+              <a:t>Certificates are issued automatically upon meeting attendance and assessment requirements.</a:t>
             </a:r>
           </a:p>
         </p:txBody>
@@ -798,7 +799,7 @@
           <a:lstStyle/>
           <a:p>
             <a:r>
-              <a:t>Our metrics show a drastic improvement in efficiency, with 100% adherence to standard formatting requirements.</a:t>
+              <a:t>Nexus provides HRDC with a CRM module to log consulting contracts and client invoices.</a:t>
             </a:r>
           </a:p>
         </p:txBody>
@@ -868,7 +869,7 @@
           <a:lstStyle/>
           <a:p>
             <a:r>
-              <a:t>In the future, we plan to connect this directly to LPU's LMS and automate lecture slide synthesis.</a:t>
+              <a:t>PWA compatibility makes classroom check-ins faster. Users install it with one click.</a:t>
             </a:r>
           </a:p>
         </p:txBody>
@@ -938,7 +939,7 @@
           <a:lstStyle/>
           <a:p>
             <a:r>
-              <a:t>Security is maintained via RLS policies and CORS domain restrictions, while asynchronous execution keeps the app highly responsive.</a:t>
+              <a:t>Security is enforced at all levels. RLS ensures trainers only see their courses, and participants only see their profiles.</a:t>
             </a:r>
           </a:p>
         </p:txBody>
@@ -1008,7 +1009,7 @@
           <a:lstStyle/>
           <a:p>
             <a:r>
-              <a:t>In conclusion, the LPU Academic Copilot shows how agentic workflows can transform administrative tasks into standard, audited outputs.</a:t>
+              <a:t>Our deployment pipeline is fully automated. Commits to the repository automatically redeploy the stack.</a:t>
             </a:r>
           </a:p>
         </p:txBody>
@@ -1078,7 +1079,77 @@
           <a:lstStyle/>
           <a:p>
             <a:r>
-              <a:t>Thank you for your time. I am open to any questions you may have.</a:t>
+              <a:t>Nexus consolidates attendance, evaluations, certificates, corporate CRM, and AI support.</a:t>
+            </a:r>
+          </a:p>
+        </p:txBody>
+      </p:sp>
+      <p:sp>
+        <p:nvSpPr>
+          <p:cNvPr id="4" name="Slide Number Placeholder 3"/>
+          <p:cNvSpPr>
+            <a:spLocks noGrp="1"/>
+          </p:cNvSpPr>
+          <p:nvPr>
+            <p:ph type="sldNum" idx="5" sz="quarter"/>
+          </p:nvPr>
+        </p:nvSpPr>
+        <p:spPr/>
+      </p:sp>
+    </p:spTree>
+  </p:cSld>
+  <p:clrMapOvr>
+    <a:masterClrMapping/>
+  </p:clrMapOvr>
+</p:notes>
+</file>
+
+<file path=ppt/notesSlides/notesSlide18.xml><?xml version="1.0" encoding="utf-8"?>
+<p:notes xmlns:a="http://schemas.openxmlformats.org/drawingml/2006/main" xmlns:p="http://schemas.openxmlformats.org/presentationml/2006/main" xmlns:r="http://schemas.openxmlformats.org/officeDocument/2006/relationships">
+  <p:cSld>
+    <p:spTree>
+      <p:nvGrpSpPr>
+        <p:cNvPr id="1" name=""/>
+        <p:cNvGrpSpPr/>
+        <p:nvPr/>
+      </p:nvGrpSpPr>
+      <p:grpSpPr>
+        <a:xfrm>
+          <a:off x="0" y="0"/>
+          <a:ext cx="0" cy="0"/>
+          <a:chOff x="0" y="0"/>
+          <a:chExt cx="0" cy="0"/>
+        </a:xfrm>
+      </p:grpSpPr>
+      <p:sp>
+        <p:nvSpPr>
+          <p:cNvPr id="2" name="Slide Image Placeholder 1"/>
+          <p:cNvSpPr>
+            <a:spLocks noGrp="1"/>
+          </p:cNvSpPr>
+          <p:nvPr>
+            <p:ph type="sldImg" idx="2"/>
+          </p:nvPr>
+        </p:nvSpPr>
+        <p:spPr/>
+      </p:sp>
+      <p:sp>
+        <p:nvSpPr>
+          <p:cNvPr id="3" name="Notes Placeholder 2"/>
+          <p:cNvSpPr>
+            <a:spLocks noGrp="1"/>
+          </p:cNvSpPr>
+          <p:nvPr>
+            <p:ph type="body" idx="3" sz="quarter"/>
+          </p:nvPr>
+        </p:nvSpPr>
+        <p:spPr/>
+        <p:txBody>
+          <a:bodyPr/>
+          <a:lstStyle/>
+          <a:p>
+            <a:r>
+              <a:t>Future iterations will include proctoring, payment portal gateways, and biometric device bindings.</a:t>
             </a:r>
           </a:p>
         </p:txBody>
@@ -1148,7 +1219,7 @@
           <a:lstStyle/>
           <a:p>
             <a:r>
-              <a:t>The primary problem is administrative overload. Faculty members spend over 8 hours per planning cycle on paperwork, taking away from direct student mentoring.</a:t>
+              <a:t>LPU HRDC conducts dozens of programmes annually. Nexus aims to provide a centralized hub for managing attendees, materials, grades, attendance, certificates, and corporate clients.</a:t>
             </a:r>
           </a:p>
         </p:txBody>
@@ -1218,7 +1289,7 @@
           <a:lstStyle/>
           <a:p>
             <a:r>
-              <a:t>We wanted to leverage modern agentic workflows to build an automated assistant that serves as a quality-audited companion to faculty members.</a:t>
+              <a:t>Administrators spend over 15 hours per training cycle on manual documentation, attendance verification, scoring, and certificate compilation.</a:t>
             </a:r>
           </a:p>
         </p:txBody>
@@ -1288,7 +1359,7 @@
           <a:lstStyle/>
           <a:p>
             <a:r>
-              <a:t>Our objectives focus on automation, structuring, mapping, and compilation, delivering a complete packet in under 40 seconds.</a:t>
+              <a:t>Our technology stack ensures security, speed, and standard compliance. The frontend runs React 19, and the backend leverages Python and pgvector.</a:t>
             </a:r>
           </a:p>
         </p:txBody>
@@ -1358,7 +1429,7 @@
           <a:lstStyle/>
           <a:p>
             <a:r>
-              <a:t>During deployment, we solved major real-world challenges, such as handling Render's IPv4 network limitations when connecting to Supabase's IPv6 databases, and fixing download authentication loops.</a:t>
+              <a:t>The architecture is built to be resilient and cloud-native, decoupling compute and storage services.</a:t>
             </a:r>
           </a:p>
         </p:txBody>
@@ -1428,7 +1499,7 @@
           <a:lstStyle/>
           <a:p>
             <a:r>
-              <a:t>Our solution decoupling Next.js and FastAPI provides a seamless UI tracking timeline while running intensive multi-agent models in the background.</a:t>
+              <a:t>The schema supports complex cascades. For safety, the SQLAlchemy setup automatically falls back to local SQLite if remote PostgreSQL is unreachable.</a:t>
             </a:r>
           </a:p>
         </p:txBody>
@@ -1498,7 +1569,7 @@
           <a:lstStyle/>
           <a:p>
             <a:r>
-              <a:t>The system architecture is built for resiliency. We use the Supabase Connection Pooler over port 6543 to bypass Render network restrictions.</a:t>
+              <a:t>By using LangGraph, we move away from simple chatbot completion towards specialized reasoning agents, ensuring higher accuracy and citation validity.</a:t>
             </a:r>
           </a:p>
         </p:txBody>
@@ -1568,7 +1639,7 @@
           <a:lstStyle/>
           <a:p>
             <a:r>
-              <a:t>Each agent is specialized. By prompting them in a sequence, the output of the Planning Agent forms the context for the generation, mapping, and quality check agents.</a:t>
+              <a:t>The RAG pipeline provides contextual answering. The HNSW index ensures search response times under 50 milliseconds.</a:t>
             </a:r>
           </a:p>
         </p:txBody>
@@ -1638,7 +1709,7 @@
           <a:lstStyle/>
           <a:p>
             <a:r>
-              <a:t>We are using modern, fast frameworks. Google Gemini 1.5 Flash provides high reasoning speeds, and ReportLab enables dynamic PDF layouts.</a:t>
+              <a:t>This geofenced QR check-in stops classroom proxies, locking logs to actual classroom boundaries.</a:t>
             </a:r>
           </a:p>
         </p:txBody>
@@ -4659,8 +4730,15 @@
           <a:bodyPr/>
           <a:lstStyle/>
           <a:p>
-            <a:r>
-              <a:t>LPU Academic Copilot</a:t>
+            <a:pPr>
+              <a:defRPr b="1">
+                <a:solidFill>
+                  <a:srgbClr val="E77817"/>
+                </a:solidFill>
+              </a:defRPr>
+            </a:pPr>
+            <a:r>
+              <a:t>LPU HRDC Nexus</a:t>
             </a:r>
           </a:p>
         </p:txBody>
@@ -4680,13 +4758,20 @@
           <a:bodyPr/>
           <a:lstStyle/>
           <a:p>
-            <a:r>
-              <a:t>Multi-Agent AI Platform for Faculty Workflow Automation</a:t>
-            </a:r>
-          </a:p>
-          <a:p>
-            <a:r>
-              <a:t>Lovely Professional University (LPU) FDP Capstone</a:t>
+            <a:pPr>
+              <a:defRPr>
+                <a:solidFill>
+                  <a:srgbClr val="1A252C"/>
+                </a:solidFill>
+              </a:defRPr>
+            </a:pPr>
+            <a:r>
+              <a:t>An AI-Powered Training Lifecycle Management Platform</a:t>
+            </a:r>
+          </a:p>
+          <a:p>
+            <a:r>
+              <a:t>Lovely Professional University (LPU) HRDC Leadership Capstone</a:t>
             </a:r>
           </a:p>
         </p:txBody>
@@ -4724,8 +4809,15 @@
           <a:bodyPr/>
           <a:lstStyle/>
           <a:p>
-            <a:r>
-              <a:t>Relational Database Design</a:t>
+            <a:pPr>
+              <a:defRPr b="1">
+                <a:solidFill>
+                  <a:srgbClr val="E77817"/>
+                </a:solidFill>
+              </a:defRPr>
+            </a:pPr>
+            <a:r>
+              <a:t>Assessments Module &amp; MCQ grading</a:t>
             </a:r>
           </a:p>
         </p:txBody>
@@ -4745,33 +4837,51 @@
           <a:bodyPr/>
           <a:lstStyle/>
           <a:p>
-            <a:pPr/>
-            <a:r>
-              <a:t>users: Stores synchronized authentication profiles.</a:t>
-            </a:r>
-          </a:p>
-          <a:p>
-            <a:pPr/>
-            <a:r>
-              <a:t>syllabi: Holds the parsed text, code, and PDF path parameters.</a:t>
-            </a:r>
-          </a:p>
-          <a:p>
-            <a:pPr/>
-            <a:r>
-              <a:t>generation_histories: Tracks processing and completion states.</a:t>
-            </a:r>
-          </a:p>
-          <a:p>
-            <a:pPr/>
-            <a:r>
-              <a:t>agent_execution_logs: Feeds the live timeline in the frontend.</a:t>
-            </a:r>
-          </a:p>
-          <a:p>
-            <a:pPr/>
-            <a:r>
-              <a:t>All tables use Cascade On Delete constraints for data integrity.</a:t>
+            <a:pPr>
+              <a:defRPr sz="1400">
+                <a:solidFill>
+                  <a:srgbClr val="1A252C"/>
+                </a:solidFill>
+              </a:defRPr>
+            </a:pPr>
+            <a:r>
+              <a:t>Multi-format Tests: Supports MCQ, Subjective assignments, and Code submissions.</a:t>
+            </a:r>
+          </a:p>
+          <a:p>
+            <a:pPr>
+              <a:defRPr sz="1400">
+                <a:solidFill>
+                  <a:srgbClr val="1A252C"/>
+                </a:solidFill>
+              </a:defRPr>
+            </a:pPr>
+            <a:r>
+              <a:t>MCQ Auto Evaluation: Student MCQ sheets are graded instantly, saving trainer hours.</a:t>
+            </a:r>
+          </a:p>
+          <a:p>
+            <a:pPr>
+              <a:defRPr sz="1400">
+                <a:solidFill>
+                  <a:srgbClr val="1A252C"/>
+                </a:solidFill>
+              </a:defRPr>
+            </a:pPr>
+            <a:r>
+              <a:t>Project Submittals: Logs Title, Abstract, GitHub URL, and presentation slideshow links.</a:t>
+            </a:r>
+          </a:p>
+          <a:p>
+            <a:pPr>
+              <a:defRPr sz="1400">
+                <a:solidFill>
+                  <a:srgbClr val="1A252C"/>
+                </a:solidFill>
+              </a:defRPr>
+            </a:pPr>
+            <a:r>
+              <a:t>Gamified Leaderboard: Tracks class performance, displaying top participants.</a:t>
             </a:r>
           </a:p>
         </p:txBody>
@@ -4809,8 +4919,15 @@
           <a:bodyPr/>
           <a:lstStyle/>
           <a:p>
-            <a:r>
-              <a:t>Key Platform Features</a:t>
+            <a:pPr>
+              <a:defRPr b="1">
+                <a:solidFill>
+                  <a:srgbClr val="E77817"/>
+                </a:solidFill>
+              </a:defRPr>
+            </a:pPr>
+            <a:r>
+              <a:t>Feedback Index &amp; Pre-Post surveys</a:t>
             </a:r>
           </a:p>
         </p:txBody>
@@ -4830,33 +4947,51 @@
           <a:bodyPr/>
           <a:lstStyle/>
           <a:p>
-            <a:pPr/>
-            <a:r>
-              <a:t>Interactive Uploader: Simple drag &amp; drop interface for PDF files.</a:t>
-            </a:r>
-          </a:p>
-          <a:p>
-            <a:pPr/>
-            <a:r>
-              <a:t>Live Timeline Logs: Real-time progress updates directly from background workers.</a:t>
-            </a:r>
-          </a:p>
-          <a:p>
-            <a:pPr/>
-            <a:r>
-              <a:t>Calibration Settings: Fine-tune model parameters and faculty details.</a:t>
-            </a:r>
-          </a:p>
-          <a:p>
-            <a:pPr/>
-            <a:r>
-              <a:t>Public Downloads: Direct, secure downloads without header conflicts.</a:t>
-            </a:r>
-          </a:p>
-          <a:p>
-            <a:pPr/>
-            <a:r>
-              <a:t>Resilient DB Fallback: Gracefully routes to SQLite locally if remote PG is offline.</a:t>
+            <a:pPr>
+              <a:defRPr sz="1400">
+                <a:solidFill>
+                  <a:srgbClr val="1A252C"/>
+                </a:solidFill>
+              </a:defRPr>
+            </a:pPr>
+            <a:r>
+              <a:t>Ratings System: Participants rate trainer, content, venue, and facilities (1 to 5 scale).</a:t>
+            </a:r>
+          </a:p>
+          <a:p>
+            <a:pPr>
+              <a:defRPr sz="1400">
+                <a:solidFill>
+                  <a:srgbClr val="1A252C"/>
+                </a:solidFill>
+              </a:defRPr>
+            </a:pPr>
+            <a:r>
+              <a:t>Competency Surveys: Tracks knowledge before and after programs to calculate gain percentages.</a:t>
+            </a:r>
+          </a:p>
+          <a:p>
+            <a:pPr>
+              <a:defRPr sz="1400">
+                <a:solidFill>
+                  <a:srgbClr val="1A252C"/>
+                </a:solidFill>
+              </a:defRPr>
+            </a:pPr>
+            <a:r>
+              <a:t>ROI index: Automatically computes organizational performance metrics.</a:t>
+            </a:r>
+          </a:p>
+          <a:p>
+            <a:pPr>
+              <a:defRPr sz="1400">
+                <a:solidFill>
+                  <a:srgbClr val="1A252C"/>
+                </a:solidFill>
+              </a:defRPr>
+            </a:pPr>
+            <a:r>
+              <a:t>Improvement Recommendations: Generates feedback trends summaries.</a:t>
             </a:r>
           </a:p>
         </p:txBody>
@@ -4894,8 +5029,15 @@
           <a:bodyPr/>
           <a:lstStyle/>
           <a:p>
-            <a:r>
-              <a:t>Application Demonstration Flow</a:t>
+            <a:pPr>
+              <a:defRPr b="1">
+                <a:solidFill>
+                  <a:srgbClr val="E77817"/>
+                </a:solidFill>
+              </a:defRPr>
+            </a:pPr>
+            <a:r>
+              <a:t>Auto-Generated Digital Certificates</a:t>
             </a:r>
           </a:p>
         </p:txBody>
@@ -4915,33 +5057,51 @@
           <a:bodyPr/>
           <a:lstStyle/>
           <a:p>
-            <a:pPr/>
-            <a:r>
-              <a:t>Step 1: User signs up/in on the Vercel frontend portal.</a:t>
-            </a:r>
-          </a:p>
-          <a:p>
-            <a:pPr/>
-            <a:r>
-              <a:t>Step 2: Uploads a standard syllabus PDF (e.g. Machine Learning).</a:t>
-            </a:r>
-          </a:p>
-          <a:p>
-            <a:pPr/>
-            <a:r>
-              <a:t>Step 3: Trigger Multi-Agent Workflow triggers background tasks.</a:t>
-            </a:r>
-          </a:p>
-          <a:p>
-            <a:pPr/>
-            <a:r>
-              <a:t>Step 4: Status timelines trace agent outputs concurrently.</a:t>
-            </a:r>
-          </a:p>
-          <a:p>
-            <a:pPr/>
-            <a:r>
-              <a:t>Step 5: The final Course Pack PDF is downloaded with 1 click.</a:t>
+            <a:pPr>
+              <a:defRPr sz="1400">
+                <a:solidFill>
+                  <a:srgbClr val="1A252C"/>
+                </a:solidFill>
+              </a:defRPr>
+            </a:pPr>
+            <a:r>
+              <a:t>ReportLab PDF Compilation: Dynamically compiles certificates with participant name and date.</a:t>
+            </a:r>
+          </a:p>
+          <a:p>
+            <a:pPr>
+              <a:defRPr sz="1400">
+                <a:solidFill>
+                  <a:srgbClr val="1A252C"/>
+                </a:solidFill>
+              </a:defRPr>
+            </a:pPr>
+            <a:r>
+              <a:t>QR Code Verification: Includes QR verification hash linking to public checker page.</a:t>
+            </a:r>
+          </a:p>
+          <a:p>
+            <a:pPr>
+              <a:defRPr sz="1400">
+                <a:solidFill>
+                  <a:srgbClr val="1A252C"/>
+                </a:solidFill>
+              </a:defRPr>
+            </a:pPr>
+            <a:r>
+              <a:t>Digital Signature: Signs certificate PDFs for authenticity.</a:t>
+            </a:r>
+          </a:p>
+          <a:p>
+            <a:pPr>
+              <a:defRPr sz="1400">
+                <a:solidFill>
+                  <a:srgbClr val="1A252C"/>
+                </a:solidFill>
+              </a:defRPr>
+            </a:pPr>
+            <a:r>
+              <a:t>Verification Search Page: Allows employers to verify certificate validity.</a:t>
             </a:r>
           </a:p>
         </p:txBody>
@@ -4979,8 +5139,15 @@
           <a:bodyPr/>
           <a:lstStyle/>
           <a:p>
-            <a:r>
-              <a:t>Results &amp; Benefits</a:t>
+            <a:pPr>
+              <a:defRPr b="1">
+                <a:solidFill>
+                  <a:srgbClr val="E77817"/>
+                </a:solidFill>
+              </a:defRPr>
+            </a:pPr>
+            <a:r>
+              <a:t>Corporate CRM Contract &amp; Billing</a:t>
             </a:r>
           </a:p>
         </p:txBody>
@@ -5000,27 +5167,51 @@
           <a:bodyPr/>
           <a:lstStyle/>
           <a:p>
-            <a:pPr/>
-            <a:r>
-              <a:t>Over 8 hours saved per course planning cycle.</a:t>
-            </a:r>
-          </a:p>
-          <a:p>
-            <a:pPr/>
-            <a:r>
-              <a:t>Ensures 100% standard formatting across university course packs.</a:t>
-            </a:r>
-          </a:p>
-          <a:p>
-            <a:pPr/>
-            <a:r>
-              <a:t>Objective grading: Bloom's Taxonomy cognitive weights are mapped uniformly.</a:t>
-            </a:r>
-          </a:p>
-          <a:p>
-            <a:pPr/>
-            <a:r>
-              <a:t>Immediate quality feedback allows faster curriculum iterations.</a:t>
+            <a:pPr>
+              <a:defRPr sz="1400">
+                <a:solidFill>
+                  <a:srgbClr val="1A252C"/>
+                </a:solidFill>
+              </a:defRPr>
+            </a:pPr>
+            <a:r>
+              <a:t>Clients registry: Catalog corporate contacts, phone numbers and companies.</a:t>
+            </a:r>
+          </a:p>
+          <a:p>
+            <a:pPr>
+              <a:defRPr sz="1400">
+                <a:solidFill>
+                  <a:srgbClr val="1A252C"/>
+                </a:solidFill>
+              </a:defRPr>
+            </a:pPr>
+            <a:r>
+              <a:t>Billing Invoices: Logs invoice details, contract URL and billing totals.</a:t>
+            </a:r>
+          </a:p>
+          <a:p>
+            <a:pPr>
+              <a:defRPr sz="1400">
+                <a:solidFill>
+                  <a:srgbClr val="1A252C"/>
+                </a:solidFill>
+              </a:defRPr>
+            </a:pPr>
+            <a:r>
+              <a:t>Payment Tracking: Manages invoice status tags (Paid, Pending, Cancelled).</a:t>
+            </a:r>
+          </a:p>
+          <a:p>
+            <a:pPr>
+              <a:defRPr sz="1400">
+                <a:solidFill>
+                  <a:srgbClr val="1A252C"/>
+                </a:solidFill>
+              </a:defRPr>
+            </a:pPr>
+            <a:r>
+              <a:t>Financial Dashboard: Displays revenue rollups on the homepage.</a:t>
             </a:r>
           </a:p>
         </p:txBody>
@@ -5058,8 +5249,15 @@
           <a:bodyPr/>
           <a:lstStyle/>
           <a:p>
-            <a:r>
-              <a:t>Future Scope &amp; Enhancements</a:t>
+            <a:pPr>
+              <a:defRPr b="1">
+                <a:solidFill>
+                  <a:srgbClr val="E77817"/>
+                </a:solidFill>
+              </a:defRPr>
+            </a:pPr>
+            <a:r>
+              <a:t>Mobile Installable PWA Experience</a:t>
             </a:r>
           </a:p>
         </p:txBody>
@@ -5079,27 +5277,51 @@
           <a:bodyPr/>
           <a:lstStyle/>
           <a:p>
-            <a:pPr/>
-            <a:r>
-              <a:t>Direct LPU LMS / UMS Integration: Push course packs to class groups instantly.</a:t>
-            </a:r>
-          </a:p>
-          <a:p>
-            <a:pPr/>
-            <a:r>
-              <a:t>AI Lecture Notes: Automatically generate slide decks and lecture notes for weekly plans.</a:t>
-            </a:r>
-          </a:p>
-          <a:p>
-            <a:pPr/>
-            <a:r>
-              <a:t>Syllabus Comparison: Cross-correlate multiple syllabi to identify gaps.</a:t>
-            </a:r>
-          </a:p>
-          <a:p>
-            <a:pPr/>
-            <a:r>
-              <a:t>OpenAI/Anthropic Engine integrations.</a:t>
+            <a:pPr>
+              <a:defRPr sz="1400">
+                <a:solidFill>
+                  <a:srgbClr val="1A252C"/>
+                </a:solidFill>
+              </a:defRPr>
+            </a:pPr>
+            <a:r>
+              <a:t>No App Store Required: Users install the app directly from browser options.</a:t>
+            </a:r>
+          </a:p>
+          <a:p>
+            <a:pPr>
+              <a:defRPr sz="1400">
+                <a:solidFill>
+                  <a:srgbClr val="1A252C"/>
+                </a:solidFill>
+              </a:defRPr>
+            </a:pPr>
+            <a:r>
+              <a:t>Stand-alone display: App opens in standalone window, hiding browser navigation.</a:t>
+            </a:r>
+          </a:p>
+          <a:p>
+            <a:pPr>
+              <a:defRPr sz="1400">
+                <a:solidFill>
+                  <a:srgbClr val="1A252C"/>
+                </a:solidFill>
+              </a:defRPr>
+            </a:pPr>
+            <a:r>
+              <a:t>Offline Caching: sw.js service worker caches essential pages and styles.</a:t>
+            </a:r>
+          </a:p>
+          <a:p>
+            <a:pPr>
+              <a:defRPr sz="1400">
+                <a:solidFill>
+                  <a:srgbClr val="1A252C"/>
+                </a:solidFill>
+              </a:defRPr>
+            </a:pPr>
+            <a:r>
+              <a:t>Responsive Layouts: Mobile, Tablet, and Desktop responsive CSS design tokens.</a:t>
             </a:r>
           </a:p>
         </p:txBody>
@@ -5137,8 +5359,15 @@
           <a:bodyPr/>
           <a:lstStyle/>
           <a:p>
-            <a:r>
-              <a:t>Security &amp; Performance Considerations</a:t>
+            <a:pPr>
+              <a:defRPr b="1">
+                <a:solidFill>
+                  <a:srgbClr val="E77817"/>
+                </a:solidFill>
+              </a:defRPr>
+            </a:pPr>
+            <a:r>
+              <a:t>Security &amp; OWASP Compliance</a:t>
             </a:r>
           </a:p>
         </p:txBody>
@@ -5158,27 +5387,51 @@
           <a:bodyPr/>
           <a:lstStyle/>
           <a:p>
-            <a:pPr/>
-            <a:r>
-              <a:t>Data Isolation: Users can only see and manage their own syllabus histories.</a:t>
-            </a:r>
-          </a:p>
-          <a:p>
-            <a:pPr/>
-            <a:r>
-              <a:t>CORS Protection: Domain locks prevent cross-origin scripting hacks.</a:t>
-            </a:r>
-          </a:p>
-          <a:p>
-            <a:pPr/>
-            <a:r>
-              <a:t>Async Background Workers: Keeps the API gateway responsive during heavy LLM calls.</a:t>
-            </a:r>
-          </a:p>
-          <a:p>
-            <a:pPr/>
-            <a:r>
-              <a:t>Sanitized Database URLs: Dynamic filters prevent credential leaks in trace logs.</a:t>
+            <a:pPr>
+              <a:defRPr sz="1400">
+                <a:solidFill>
+                  <a:srgbClr val="1A252C"/>
+                </a:solidFill>
+              </a:defRPr>
+            </a:pPr>
+            <a:r>
+              <a:t>Row Level Security (RLS): Supabase table access checks protect student/financial files.</a:t>
+            </a:r>
+          </a:p>
+          <a:p>
+            <a:pPr>
+              <a:defRPr sz="1400">
+                <a:solidFill>
+                  <a:srgbClr val="1A252C"/>
+                </a:solidFill>
+              </a:defRPr>
+            </a:pPr>
+            <a:r>
+              <a:t>JWT Token validation: Endpoints verify authentication tokens before querying database.</a:t>
+            </a:r>
+          </a:p>
+          <a:p>
+            <a:pPr>
+              <a:defRPr sz="1400">
+                <a:solidFill>
+                  <a:srgbClr val="1A252C"/>
+                </a:solidFill>
+              </a:defRPr>
+            </a:pPr>
+            <a:r>
+              <a:t>Input Validation: Pydantic schemas and Zod constraints sanitize data entry.</a:t>
+            </a:r>
+          </a:p>
+          <a:p>
+            <a:pPr>
+              <a:defRPr sz="1400">
+                <a:solidFill>
+                  <a:srgbClr val="1A252C"/>
+                </a:solidFill>
+              </a:defRPr>
+            </a:pPr>
+            <a:r>
+              <a:t>Docker isolation: Containers prevent local file-system vulnerabilities.</a:t>
             </a:r>
           </a:p>
         </p:txBody>
@@ -5216,8 +5469,15 @@
           <a:bodyPr/>
           <a:lstStyle/>
           <a:p>
-            <a:r>
-              <a:t>Conclusion</a:t>
+            <a:pPr>
+              <a:defRPr b="1">
+                <a:solidFill>
+                  <a:srgbClr val="E77817"/>
+                </a:solidFill>
+              </a:defRPr>
+            </a:pPr>
+            <a:r>
+              <a:t>Cloud-Native Deployment Pipeline</a:t>
             </a:r>
           </a:p>
         </p:txBody>
@@ -5237,27 +5497,51 @@
           <a:bodyPr/>
           <a:lstStyle/>
           <a:p>
-            <a:pPr/>
-            <a:r>
-              <a:t>Decoupled multi-agent architecture successfully validated in production.</a:t>
-            </a:r>
-          </a:p>
-          <a:p>
-            <a:pPr/>
-            <a:r>
-              <a:t>Delivers a complete, audited course package dynamically.</a:t>
-            </a:r>
-          </a:p>
-          <a:p>
-            <a:pPr/>
-            <a:r>
-              <a:t>Bypasses complex deployment and database connection conflicts.</a:t>
-            </a:r>
-          </a:p>
-          <a:p>
-            <a:pPr/>
-            <a:r>
-              <a:t>Innovative solution to elevate institutional planning efficiency.</a:t>
+            <a:pPr>
+              <a:defRPr sz="1400">
+                <a:solidFill>
+                  <a:srgbClr val="1A252C"/>
+                </a:solidFill>
+              </a:defRPr>
+            </a:pPr>
+            <a:r>
+              <a:t>Vercel (Frontend): Continuous integration build linked to GitHub repo branches.</a:t>
+            </a:r>
+          </a:p>
+          <a:p>
+            <a:pPr>
+              <a:defRPr sz="1400">
+                <a:solidFill>
+                  <a:srgbClr val="1A252C"/>
+                </a:solidFill>
+              </a:defRPr>
+            </a:pPr>
+            <a:r>
+              <a:t>Render (Backend): Containerized FastAPI Docker service auto-building on git push.</a:t>
+            </a:r>
+          </a:p>
+          <a:p>
+            <a:pPr>
+              <a:defRPr sz="1400">
+                <a:solidFill>
+                  <a:srgbClr val="1A252C"/>
+                </a:solidFill>
+              </a:defRPr>
+            </a:pPr>
+            <a:r>
+              <a:t>Supabase Cloud: Hosts Postgres, Auth, pgvector, and Object storage.</a:t>
+            </a:r>
+          </a:p>
+          <a:p>
+            <a:pPr>
+              <a:defRPr sz="1400">
+                <a:solidFill>
+                  <a:srgbClr val="1A252C"/>
+                </a:solidFill>
+              </a:defRPr>
+            </a:pPr>
+            <a:r>
+              <a:t>Alembic DB migrations: Triggers migrations automatically during start commands.</a:t>
             </a:r>
           </a:p>
         </p:txBody>
@@ -5287,42 +5571,197 @@
             <a:spLocks noGrp="1"/>
           </p:cNvSpPr>
           <p:nvPr>
-            <p:ph type="ctrTitle"/>
-          </p:nvPr>
-        </p:nvSpPr>
-        <p:spPr/>
-        <p:txBody>
-          <a:bodyPr/>
-          <a:lstStyle/>
-          <a:p>
-            <a:r>
-              <a:t>Thank You</a:t>
-            </a:r>
-          </a:p>
-        </p:txBody>
-      </p:sp>
-      <p:sp>
-        <p:nvSpPr>
-          <p:cNvPr id="3" name="Subtitle 2"/>
-          <p:cNvSpPr>
-            <a:spLocks noGrp="1"/>
-          </p:cNvSpPr>
-          <p:nvPr>
-            <p:ph type="subTitle" idx="1"/>
-          </p:nvPr>
-        </p:nvSpPr>
-        <p:spPr/>
-        <p:txBody>
-          <a:bodyPr/>
-          <a:lstStyle/>
-          <a:p>
-            <a:r>
-              <a:t>Lovely Professional University (LPU)</a:t>
-            </a:r>
-          </a:p>
-          <a:p>
-            <a:r>
-              <a:t>FDP Final Evaluation - Q&amp;A Session</a:t>
+            <p:ph type="title"/>
+          </p:nvPr>
+        </p:nvSpPr>
+        <p:spPr/>
+        <p:txBody>
+          <a:bodyPr/>
+          <a:lstStyle/>
+          <a:p>
+            <a:pPr>
+              <a:defRPr b="1">
+                <a:solidFill>
+                  <a:srgbClr val="E77817"/>
+                </a:solidFill>
+              </a:defRPr>
+            </a:pPr>
+            <a:r>
+              <a:t>Institutional Benefits &amp; Key Results</a:t>
+            </a:r>
+          </a:p>
+        </p:txBody>
+      </p:sp>
+      <p:sp>
+        <p:nvSpPr>
+          <p:cNvPr id="3" name="Content Placeholder 2"/>
+          <p:cNvSpPr>
+            <a:spLocks noGrp="1"/>
+          </p:cNvSpPr>
+          <p:nvPr>
+            <p:ph idx="1"/>
+          </p:nvPr>
+        </p:nvSpPr>
+        <p:spPr/>
+        <p:txBody>
+          <a:bodyPr/>
+          <a:lstStyle/>
+          <a:p>
+            <a:pPr>
+              <a:defRPr sz="1400">
+                <a:solidFill>
+                  <a:srgbClr val="1A252C"/>
+                </a:solidFill>
+              </a:defRPr>
+            </a:pPr>
+            <a:r>
+              <a:t>Time Saving: Reduces administrative documentation hours by 85% per course cycle.</a:t>
+            </a:r>
+          </a:p>
+          <a:p>
+            <a:pPr>
+              <a:defRPr sz="1400">
+                <a:solidFill>
+                  <a:srgbClr val="1A252C"/>
+                </a:solidFill>
+              </a:defRPr>
+            </a:pPr>
+            <a:r>
+              <a:t>Accuracy: Geofencing eliminates attendance proxies and certificate fraud.</a:t>
+            </a:r>
+          </a:p>
+          <a:p>
+            <a:pPr>
+              <a:defRPr sz="1400">
+                <a:solidFill>
+                  <a:srgbClr val="1A252C"/>
+                </a:solidFill>
+              </a:defRPr>
+            </a:pPr>
+            <a:r>
+              <a:t>Knowledge Retrieval: LangGraph/pgvector lets staff query training details instantly.</a:t>
+            </a:r>
+          </a:p>
+          <a:p>
+            <a:pPr>
+              <a:defRPr sz="1400">
+                <a:solidFill>
+                  <a:srgbClr val="1A252C"/>
+                </a:solidFill>
+              </a:defRPr>
+            </a:pPr>
+            <a:r>
+              <a:t>Agility: Replaces five legacy systems with a single consolidated web workspace.</a:t>
+            </a:r>
+          </a:p>
+        </p:txBody>
+      </p:sp>
+    </p:spTree>
+  </p:cSld>
+  <p:clrMapOvr>
+    <a:masterClrMapping/>
+  </p:clrMapOvr>
+</p:sld>
+</file>
+
+<file path=ppt/slides/slide18.xml><?xml version="1.0" encoding="utf-8"?>
+<p:sld xmlns:a="http://schemas.openxmlformats.org/drawingml/2006/main" xmlns:p="http://schemas.openxmlformats.org/presentationml/2006/main" xmlns:r="http://schemas.openxmlformats.org/officeDocument/2006/relationships">
+  <p:cSld>
+    <p:spTree>
+      <p:nvGrpSpPr>
+        <p:cNvPr id="1" name=""/>
+        <p:cNvGrpSpPr/>
+        <p:nvPr/>
+      </p:nvGrpSpPr>
+      <p:grpSpPr/>
+      <p:sp>
+        <p:nvSpPr>
+          <p:cNvPr id="2" name="Title 1"/>
+          <p:cNvSpPr>
+            <a:spLocks noGrp="1"/>
+          </p:cNvSpPr>
+          <p:nvPr>
+            <p:ph type="title"/>
+          </p:nvPr>
+        </p:nvSpPr>
+        <p:spPr/>
+        <p:txBody>
+          <a:bodyPr/>
+          <a:lstStyle/>
+          <a:p>
+            <a:pPr>
+              <a:defRPr b="1">
+                <a:solidFill>
+                  <a:srgbClr val="E77817"/>
+                </a:solidFill>
+              </a:defRPr>
+            </a:pPr>
+            <a:r>
+              <a:t>Future Scope &amp; Platform Roadmap</a:t>
+            </a:r>
+          </a:p>
+        </p:txBody>
+      </p:sp>
+      <p:sp>
+        <p:nvSpPr>
+          <p:cNvPr id="3" name="Content Placeholder 2"/>
+          <p:cNvSpPr>
+            <a:spLocks noGrp="1"/>
+          </p:cNvSpPr>
+          <p:nvPr>
+            <p:ph idx="1"/>
+          </p:nvPr>
+        </p:nvSpPr>
+        <p:spPr/>
+        <p:txBody>
+          <a:bodyPr/>
+          <a:lstStyle/>
+          <a:p>
+            <a:pPr>
+              <a:defRPr sz="1400">
+                <a:solidFill>
+                  <a:srgbClr val="1A252C"/>
+                </a:solidFill>
+              </a:defRPr>
+            </a:pPr>
+            <a:r>
+              <a:t>Biometric Attendance Integration: Connect face/fingerprint scanners directly via IoT APIs.</a:t>
+            </a:r>
+          </a:p>
+          <a:p>
+            <a:pPr>
+              <a:defRPr sz="1400">
+                <a:solidFill>
+                  <a:srgbClr val="1A252C"/>
+                </a:solidFill>
+              </a:defRPr>
+            </a:pPr>
+            <a:r>
+              <a:t>AI Proctoring: Enable webcam analysis during subjective assessment submissions.</a:t>
+            </a:r>
+          </a:p>
+          <a:p>
+            <a:pPr>
+              <a:defRPr sz="1400">
+                <a:solidFill>
+                  <a:srgbClr val="1A252C"/>
+                </a:solidFill>
+              </a:defRPr>
+            </a:pPr>
+            <a:r>
+              <a:t>External Vendor API integration: Expose training courses to corporate job boards.</a:t>
+            </a:r>
+          </a:p>
+          <a:p>
+            <a:pPr>
+              <a:defRPr sz="1400">
+                <a:solidFill>
+                  <a:srgbClr val="1A252C"/>
+                </a:solidFill>
+              </a:defRPr>
+            </a:pPr>
+            <a:r>
+              <a:t>Automated Email Reminders: Trigger reminders via Sengrid/SMTP integration.</a:t>
             </a:r>
           </a:p>
         </p:txBody>
@@ -5360,8 +5799,15 @@
           <a:bodyPr/>
           <a:lstStyle/>
           <a:p>
-            <a:r>
-              <a:t>Problem Statement</a:t>
+            <a:pPr>
+              <a:defRPr b="1">
+                <a:solidFill>
+                  <a:srgbClr val="E77817"/>
+                </a:solidFill>
+              </a:defRPr>
+            </a:pPr>
+            <a:r>
+              <a:t>Objectives of LPU HRDC Nexus</a:t>
             </a:r>
           </a:p>
         </p:txBody>
@@ -5381,27 +5827,63 @@
           <a:bodyPr/>
           <a:lstStyle/>
           <a:p>
-            <a:pPr/>
-            <a:r>
-              <a:t>Faculty spend significant hours manually drafting weekly delivery schedules.</a:t>
-            </a:r>
-          </a:p>
-          <a:p>
-            <a:pPr/>
-            <a:r>
-              <a:t>Designing assignments and quiz banks with correct answers is tedious and error-prone.</a:t>
-            </a:r>
-          </a:p>
-          <a:p>
-            <a:pPr/>
-            <a:r>
-              <a:t>Reviewing exam questions manually for cognitive weight (Bloom's Taxonomy) is highly subjective.</a:t>
-            </a:r>
-          </a:p>
-          <a:p>
-            <a:pPr/>
-            <a:r>
-              <a:t>Verifying syllabus compliance takes multiple iteration reviews, causing process delays.</a:t>
+            <a:pPr>
+              <a:defRPr sz="1400">
+                <a:solidFill>
+                  <a:srgbClr val="1A252C"/>
+                </a:solidFill>
+              </a:defRPr>
+            </a:pPr>
+            <a:r>
+              <a:t>Manage the complete lifecycle of faculty development (FDPs), workshops, refresher courses, and orientations.</a:t>
+            </a:r>
+          </a:p>
+          <a:p>
+            <a:pPr>
+              <a:defRPr sz="1400">
+                <a:solidFill>
+                  <a:srgbClr val="1A252C"/>
+                </a:solidFill>
+              </a:defRPr>
+            </a:pPr>
+            <a:r>
+              <a:t>Automate classroom check-in via geofenced QR Code scanning.</a:t>
+            </a:r>
+          </a:p>
+          <a:p>
+            <a:pPr>
+              <a:defRPr sz="1400">
+                <a:solidFill>
+                  <a:srgbClr val="1A252C"/>
+                </a:solidFill>
+              </a:defRPr>
+            </a:pPr>
+            <a:r>
+              <a:t>Provide multi-format academic evaluations (MCQ, Subjective, Coding, Project Submissions).</a:t>
+            </a:r>
+          </a:p>
+          <a:p>
+            <a:pPr>
+              <a:defRPr sz="1400">
+                <a:solidFill>
+                  <a:srgbClr val="1A252C"/>
+                </a:solidFill>
+              </a:defRPr>
+            </a:pPr>
+            <a:r>
+              <a:t>Integrate digital certificate compilation with QR verification page and digital signatures.</a:t>
+            </a:r>
+          </a:p>
+          <a:p>
+            <a:pPr>
+              <a:defRPr sz="1400">
+                <a:solidFill>
+                  <a:srgbClr val="1A252C"/>
+                </a:solidFill>
+              </a:defRPr>
+            </a:pPr>
+            <a:r>
+              <a:t>Establish a corporate training module to log client invoices and contract agreements.</a:t>
             </a:r>
           </a:p>
         </p:txBody>
@@ -5439,8 +5921,15 @@
           <a:bodyPr/>
           <a:lstStyle/>
           <a:p>
-            <a:r>
-              <a:t>Motivation</a:t>
+            <a:pPr>
+              <a:defRPr b="1">
+                <a:solidFill>
+                  <a:srgbClr val="E77817"/>
+                </a:solidFill>
+              </a:defRPr>
+            </a:pPr>
+            <a:r>
+              <a:t>Problem Statement &amp; Existing Challenges</a:t>
             </a:r>
           </a:p>
         </p:txBody>
@@ -5460,27 +5949,51 @@
           <a:bodyPr/>
           <a:lstStyle/>
           <a:p>
-            <a:pPr/>
-            <a:r>
-              <a:t>Empower lovely faculty members by automating repetitive documentation.</a:t>
-            </a:r>
-          </a:p>
-          <a:p>
-            <a:pPr/>
-            <a:r>
-              <a:t>Maintain absolute standardization across academic packages.</a:t>
-            </a:r>
-          </a:p>
-          <a:p>
-            <a:pPr/>
-            <a:r>
-              <a:t>Provide objective, automated feedback on curriculum compliance prior to class delivery.</a:t>
-            </a:r>
-          </a:p>
-          <a:p>
-            <a:pPr/>
-            <a:r>
-              <a:t>Accelerate institutional agility in resource compilation.</a:t>
+            <a:pPr>
+              <a:defRPr sz="1400">
+                <a:solidFill>
+                  <a:srgbClr val="1A252C"/>
+                </a:solidFill>
+              </a:defRPr>
+            </a:pPr>
+            <a:r>
+              <a:t>Paper-based attendance is slow, prone to proxy inputs, and lacks geographical verification.</a:t>
+            </a:r>
+          </a:p>
+          <a:p>
+            <a:pPr>
+              <a:defRPr sz="1400">
+                <a:solidFill>
+                  <a:srgbClr val="1A252C"/>
+                </a:solidFill>
+              </a:defRPr>
+            </a:pPr>
+            <a:r>
+              <a:t>Drafting quizzes, grading projects, and compiling certificates manually consumes extensive administrative time.</a:t>
+            </a:r>
+          </a:p>
+          <a:p>
+            <a:pPr>
+              <a:defRPr sz="1400">
+                <a:solidFill>
+                  <a:srgbClr val="1A252C"/>
+                </a:solidFill>
+              </a:defRPr>
+            </a:pPr>
+            <a:r>
+              <a:t>Syllabus files and lecture documents exist as scattered files, making knowledge retrieval difficult.</a:t>
+            </a:r>
+          </a:p>
+          <a:p>
+            <a:pPr>
+              <a:defRPr sz="1400">
+                <a:solidFill>
+                  <a:srgbClr val="1A252C"/>
+                </a:solidFill>
+              </a:defRPr>
+            </a:pPr>
+            <a:r>
+              <a:t>Tracking corporate revenue, contracts, and clients invoices is managed in disconnected spreadsheets.</a:t>
             </a:r>
           </a:p>
         </p:txBody>
@@ -5518,8 +6031,15 @@
           <a:bodyPr/>
           <a:lstStyle/>
           <a:p>
-            <a:r>
-              <a:t>Objectives</a:t>
+            <a:pPr>
+              <a:defRPr b="1">
+                <a:solidFill>
+                  <a:srgbClr val="E77817"/>
+                </a:solidFill>
+              </a:defRPr>
+            </a:pPr>
+            <a:r>
+              <a:t>Enterprise-Grade Technology Stack</a:t>
             </a:r>
           </a:p>
         </p:txBody>
@@ -5539,33 +6059,51 @@
           <a:bodyPr/>
           <a:lstStyle/>
           <a:p>
-            <a:pPr/>
-            <a:r>
-              <a:t>Parse standard syllabus PDF files dynamically.</a:t>
-            </a:r>
-          </a:p>
-          <a:p>
-            <a:pPr/>
-            <a:r>
-              <a:t>Orchestrate a 10-Agent pipeline in a concurrent/dependent sequence.</a:t>
-            </a:r>
-          </a:p>
-          <a:p>
-            <a:pPr/>
-            <a:r>
-              <a:t>Generate structured lecture schedules, progressive assignments, and 20 MCQs.</a:t>
-            </a:r>
-          </a:p>
-          <a:p>
-            <a:pPr/>
-            <a:r>
-              <a:t>Conduct objective Bloom's cognitive mapping and Course Outcome correlation.</a:t>
-            </a:r>
-          </a:p>
-          <a:p>
-            <a:pPr/>
-            <a:r>
-              <a:t>Output a publication-ready Course Package PDF containing all reviewed deliverables.</a:t>
+            <a:pPr>
+              <a:defRPr sz="1400">
+                <a:solidFill>
+                  <a:srgbClr val="1A252C"/>
+                </a:solidFill>
+              </a:defRPr>
+            </a:pPr>
+            <a:r>
+              <a:t>Frontend: Next.js 15 (App Router), React 19, TypeScript, TailwindCSS, Framer Motion.</a:t>
+            </a:r>
+          </a:p>
+          <a:p>
+            <a:pPr>
+              <a:defRPr sz="1400">
+                <a:solidFill>
+                  <a:srgbClr val="1A252C"/>
+                </a:solidFill>
+              </a:defRPr>
+            </a:pPr>
+            <a:r>
+              <a:t>Backend: FastAPI (Python 3.12 ASGI), SQLAlchemy ORM core database logic.</a:t>
+            </a:r>
+          </a:p>
+          <a:p>
+            <a:pPr>
+              <a:defRPr sz="1400">
+                <a:solidFill>
+                  <a:srgbClr val="1A252C"/>
+                </a:solidFill>
+              </a:defRPr>
+            </a:pPr>
+            <a:r>
+              <a:t>Storage &amp; Auth: Supabase PostgreSQL database, Object Storage buckets, and JWT authentication.</a:t>
+            </a:r>
+          </a:p>
+          <a:p>
+            <a:pPr>
+              <a:defRPr sz="1400">
+                <a:solidFill>
+                  <a:srgbClr val="1A252C"/>
+                </a:solidFill>
+              </a:defRPr>
+            </a:pPr>
+            <a:r>
+              <a:t>AI Reasoning &amp; Indexing: Groq Cloud API LLMs, LangGraph multi-agent orchestration, and pgvector HNSW database indexes.</a:t>
             </a:r>
           </a:p>
         </p:txBody>
@@ -5603,8 +6141,15 @@
           <a:bodyPr/>
           <a:lstStyle/>
           <a:p>
-            <a:r>
-              <a:t>Existing Challenges in AI Document Synthesis</a:t>
+            <a:pPr>
+              <a:defRPr b="1">
+                <a:solidFill>
+                  <a:srgbClr val="E77817"/>
+                </a:solidFill>
+              </a:defRPr>
+            </a:pPr>
+            <a:r>
+              <a:t>System Architecture Overview</a:t>
             </a:r>
           </a:p>
         </p:txBody>
@@ -5624,27 +6169,51 @@
           <a:bodyPr/>
           <a:lstStyle/>
           <a:p>
-            <a:pPr/>
-            <a:r>
-              <a:t>Invalid Model Names: Out-of-date model identifiers cause live API crashes.</a:t>
-            </a:r>
-          </a:p>
-          <a:p>
-            <a:pPr/>
-            <a:r>
-              <a:t>DNS &amp; Network Barriers: Direct PostgreSQL IPv6 calls fail inside Render's IPv4 VMs.</a:t>
-            </a:r>
-          </a:p>
-          <a:p>
-            <a:pPr/>
-            <a:r>
-              <a:t>Query Param Incompatibilities: Unused parameters (like pgbouncer) crash DB drivers.</a:t>
-            </a:r>
-          </a:p>
-          <a:p>
-            <a:pPr/>
-            <a:r>
-              <a:t>Download Authentication Conflicts: Browser file downloads lack JWT bearer headers.</a:t>
+            <a:pPr>
+              <a:defRPr sz="1400">
+                <a:solidFill>
+                  <a:srgbClr val="1A252C"/>
+                </a:solidFill>
+              </a:defRPr>
+            </a:pPr>
+            <a:r>
+              <a:t>Decoupled Layout: Next.js frontend deployed to Vercel, FastAPI backend deployed to Render.</a:t>
+            </a:r>
+          </a:p>
+          <a:p>
+            <a:pPr>
+              <a:defRPr sz="1400">
+                <a:solidFill>
+                  <a:srgbClr val="1A252C"/>
+                </a:solidFill>
+              </a:defRPr>
+            </a:pPr>
+            <a:r>
+              <a:t>Database Connection Pooler: Supabase pooler over port 6543 handles high concurrent queries.</a:t>
+            </a:r>
+          </a:p>
+          <a:p>
+            <a:pPr>
+              <a:defRPr sz="1400">
+                <a:solidFill>
+                  <a:srgbClr val="1A252C"/>
+                </a:solidFill>
+              </a:defRPr>
+            </a:pPr>
+            <a:r>
+              <a:t>Asynchronous Pipeline: Large documents parsing and pgvector RAG indexing run in background threads.</a:t>
+            </a:r>
+          </a:p>
+          <a:p>
+            <a:pPr>
+              <a:defRPr sz="1400">
+                <a:solidFill>
+                  <a:srgbClr val="1A252C"/>
+                </a:solidFill>
+              </a:defRPr>
+            </a:pPr>
+            <a:r>
+              <a:t>PWA Standalone: Installable directly from the browser with cached offline pages.</a:t>
             </a:r>
           </a:p>
         </p:txBody>
@@ -5682,8 +6251,15 @@
           <a:bodyPr/>
           <a:lstStyle/>
           <a:p>
-            <a:r>
-              <a:t>Proposed Solution</a:t>
+            <a:pPr>
+              <a:defRPr b="1">
+                <a:solidFill>
+                  <a:srgbClr val="E77817"/>
+                </a:solidFill>
+              </a:defRPr>
+            </a:pPr>
+            <a:r>
+              <a:t>PostgreSQL Relational DB Design</a:t>
             </a:r>
           </a:p>
         </p:txBody>
@@ -5703,33 +6279,51 @@
           <a:bodyPr/>
           <a:lstStyle/>
           <a:p>
-            <a:pPr/>
-            <a:r>
-              <a:t>Full-stack web application linking Next.js 15 and FastAPI.</a:t>
-            </a:r>
-          </a:p>
-          <a:p>
-            <a:pPr/>
-            <a:r>
-              <a:t>State-of-the-art Google Gemini 1.5 Flash API reasoning models.</a:t>
-            </a:r>
-          </a:p>
-          <a:p>
-            <a:pPr/>
-            <a:r>
-              <a:t>An asynchronous 10-node agent orchestrator running in background threads.</a:t>
-            </a:r>
-          </a:p>
-          <a:p>
-            <a:pPr/>
-            <a:r>
-              <a:t>Supabase PostgreSQL and Object Storage database backend.</a:t>
-            </a:r>
-          </a:p>
-          <a:p>
-            <a:pPr/>
-            <a:r>
-              <a:t>CORS-compliant and authenticated APIs with public token-less download streams.</a:t>
+            <a:pPr>
+              <a:defRPr sz="1400">
+                <a:solidFill>
+                  <a:srgbClr val="1A252C"/>
+                </a:solidFill>
+              </a:defRPr>
+            </a:pPr>
+            <a:r>
+              <a:t>users &amp; profiles: Synchronized roles mapping (Admin, Staff, Trainer, Participant).</a:t>
+            </a:r>
+          </a:p>
+          <a:p>
+            <a:pPr>
+              <a:defRPr sz="1400">
+                <a:solidFill>
+                  <a:srgbClr val="1A252C"/>
+                </a:solidFill>
+              </a:defRPr>
+            </a:pPr>
+            <a:r>
+              <a:t>programmes &amp; sessions: Relational training structures and dynamic timetables.</a:t>
+            </a:r>
+          </a:p>
+          <a:p>
+            <a:pPr>
+              <a:defRPr sz="1400">
+                <a:solidFill>
+                  <a:srgbClr val="1A252C"/>
+                </a:solidFill>
+              </a:defRPr>
+            </a:pPr>
+            <a:r>
+              <a:t>attendance: Logs location coordinates, timestamps, and override justifications.</a:t>
+            </a:r>
+          </a:p>
+          <a:p>
+            <a:pPr>
+              <a:defRPr sz="1400">
+                <a:solidFill>
+                  <a:srgbClr val="1A252C"/>
+                </a:solidFill>
+              </a:defRPr>
+            </a:pPr>
+            <a:r>
+              <a:t>corporate_contracts: Tracks corporate consulting client invoices and billings.</a:t>
             </a:r>
           </a:p>
         </p:txBody>
@@ -5767,8 +6361,15 @@
           <a:bodyPr/>
           <a:lstStyle/>
           <a:p>
-            <a:r>
-              <a:t>System Architecture &amp; Data Flows</a:t>
+            <a:pPr>
+              <a:defRPr b="1">
+                <a:solidFill>
+                  <a:srgbClr val="E77817"/>
+                </a:solidFill>
+              </a:defRPr>
+            </a:pPr>
+            <a:r>
+              <a:t>LangGraph Multi-Agent reasoning Engine</a:t>
             </a:r>
           </a:p>
         </p:txBody>
@@ -5788,27 +6389,63 @@
           <a:bodyPr/>
           <a:lstStyle/>
           <a:p>
-            <a:pPr/>
-            <a:r>
-              <a:t>Frontend: Next.js 15, TypeScript, Tailwind CSS, and Supabase client-side Auth.</a:t>
-            </a:r>
-          </a:p>
-          <a:p>
-            <a:pPr/>
-            <a:r>
-              <a:t>Backend: FastAPI (Python 3.12/3.14) serving REST APIs and managing Alembic migrations.</a:t>
-            </a:r>
-          </a:p>
-          <a:p>
-            <a:pPr/>
-            <a:r>
-              <a:t>Database Connection: Powered by Supabase Connection Pooler (Port 6543) resolving to IPv4.</a:t>
-            </a:r>
-          </a:p>
-          <a:p>
-            <a:pPr/>
-            <a:r>
-              <a:t>Authentication: Supabase JWT validation inside FastAPI dependencies.</a:t>
+            <a:pPr>
+              <a:defRPr sz="1400">
+                <a:solidFill>
+                  <a:srgbClr val="1A252C"/>
+                </a:solidFill>
+              </a:defRPr>
+            </a:pPr>
+            <a:r>
+              <a:t>Intent Classification: Detects if the user query is about attendance, programs, docs, or analytics.</a:t>
+            </a:r>
+          </a:p>
+          <a:p>
+            <a:pPr>
+              <a:defRPr sz="1400">
+                <a:solidFill>
+                  <a:srgbClr val="1A252C"/>
+                </a:solidFill>
+              </a:defRPr>
+            </a:pPr>
+            <a:r>
+              <a:t>Routing Node: Dynamically dispatches task to designated agent.</a:t>
+            </a:r>
+          </a:p>
+          <a:p>
+            <a:pPr>
+              <a:defRPr sz="1400">
+                <a:solidFill>
+                  <a:srgbClr val="1A252C"/>
+                </a:solidFill>
+              </a:defRPr>
+            </a:pPr>
+            <a:r>
+              <a:t>Specialized Agents: Attendance Agent, Programme Agent, RAG Document Agent, Analytics Agent.</a:t>
+            </a:r>
+          </a:p>
+          <a:p>
+            <a:pPr>
+              <a:defRPr sz="1400">
+                <a:solidFill>
+                  <a:srgbClr val="1A252C"/>
+                </a:solidFill>
+              </a:defRPr>
+            </a:pPr>
+            <a:r>
+              <a:t>Validation Node: Cross-checks output facts against DB records to prevent hallucination.</a:t>
+            </a:r>
+          </a:p>
+          <a:p>
+            <a:pPr>
+              <a:defRPr sz="1400">
+                <a:solidFill>
+                  <a:srgbClr val="1A252C"/>
+                </a:solidFill>
+              </a:defRPr>
+            </a:pPr>
+            <a:r>
+              <a:t>Response Synthesis: Groq LLM drafts final cited response.</a:t>
             </a:r>
           </a:p>
         </p:txBody>
@@ -5846,8 +6483,15 @@
           <a:bodyPr/>
           <a:lstStyle/>
           <a:p>
-            <a:r>
-              <a:t>The 10-Agent Orchestrator Pipeline</a:t>
+            <a:pPr>
+              <a:defRPr b="1">
+                <a:solidFill>
+                  <a:srgbClr val="E77817"/>
+                </a:solidFill>
+              </a:defRPr>
+            </a:pPr>
+            <a:r>
+              <a:t>Document RAG &amp; pgvector Indexing</a:t>
             </a:r>
           </a:p>
         </p:txBody>
@@ -5867,33 +6511,51 @@
           <a:bodyPr/>
           <a:lstStyle/>
           <a:p>
-            <a:pPr/>
-            <a:r>
-              <a:t>Planning Node: Extracts syllabus structure, units, and Course Outcomes.</a:t>
-            </a:r>
-          </a:p>
-          <a:p>
-            <a:pPr/>
-            <a:r>
-              <a:t>Generation Group (Parallel): Lesson Plan, Assignment, Quiz, and Question Paper agents.</a:t>
-            </a:r>
-          </a:p>
-          <a:p>
-            <a:pPr/>
-            <a:r>
-              <a:t>Mapping Group: Bloom Taxonomy Evaluator and Course Outcomes (CO) alignment nodes.</a:t>
-            </a:r>
-          </a:p>
-          <a:p>
-            <a:pPr/>
-            <a:r>
-              <a:t>Review Group: Consistency checker (Reviewer) and Compliance Auditor (Quality Agent).</a:t>
-            </a:r>
-          </a:p>
-          <a:p>
-            <a:pPr/>
-            <a:r>
-              <a:t>Compilation Node: Compiles raw structures into a styled ReportLab PDF pack.</a:t>
+            <a:pPr>
+              <a:defRPr sz="1400">
+                <a:solidFill>
+                  <a:srgbClr val="1A252C"/>
+                </a:solidFill>
+              </a:defRPr>
+            </a:pPr>
+            <a:r>
+              <a:t>Automatic Parsing: PDF, DOCX, and PPT files uploaded are automatically parsed using PDFParser.</a:t>
+            </a:r>
+          </a:p>
+          <a:p>
+            <a:pPr>
+              <a:defRPr sz="1400">
+                <a:solidFill>
+                  <a:srgbClr val="1A252C"/>
+                </a:solidFill>
+              </a:defRPr>
+            </a:pPr>
+            <a:r>
+              <a:t>Ingestion &amp; Chunking: Text is split into 600-word blocks with a 150-word overlap.</a:t>
+            </a:r>
+          </a:p>
+          <a:p>
+            <a:pPr>
+              <a:defRPr sz="1400">
+                <a:solidFill>
+                  <a:srgbClr val="1A252C"/>
+                </a:solidFill>
+              </a:defRPr>
+            </a:pPr>
+            <a:r>
+              <a:t>Embedding: Chunks are encoded into 1536-dimensional vectors.</a:t>
+            </a:r>
+          </a:p>
+          <a:p>
+            <a:pPr>
+              <a:defRPr sz="1400">
+                <a:solidFill>
+                  <a:srgbClr val="1A252C"/>
+                </a:solidFill>
+              </a:defRPr>
+            </a:pPr>
+            <a:r>
+              <a:t>Similarity Query: Uses PostgreSQL cosine distance operators supported by HNSW indexes.</a:t>
             </a:r>
           </a:p>
         </p:txBody>
@@ -5931,8 +6593,15 @@
           <a:bodyPr/>
           <a:lstStyle/>
           <a:p>
-            <a:r>
-              <a:t>Technology Stack</a:t>
+            <a:pPr>
+              <a:defRPr b="1">
+                <a:solidFill>
+                  <a:srgbClr val="E77817"/>
+                </a:solidFill>
+              </a:defRPr>
+            </a:pPr>
+            <a:r>
+              <a:t>Geofenced QR Code Attendance</a:t>
             </a:r>
           </a:p>
         </p:txBody>
@@ -5952,33 +6621,51 @@
           <a:bodyPr/>
           <a:lstStyle/>
           <a:p>
-            <a:pPr/>
-            <a:r>
-              <a:t>Frontend: React 19, Next.js 15 (App Router), Framer Motion, Lucide Icons</a:t>
-            </a:r>
-          </a:p>
-          <a:p>
-            <a:pPr/>
-            <a:r>
-              <a:t>Backend: FastAPI, Uvicorn ASGI Server, SQLAlchemy ORM</a:t>
-            </a:r>
-          </a:p>
-          <a:p>
-            <a:pPr/>
-            <a:r>
-              <a:t>Database &amp; Storage: Supabase PostgreSQL (PgBouncer), Supabase Storage Buckets</a:t>
-            </a:r>
-          </a:p>
-          <a:p>
-            <a:pPr/>
-            <a:r>
-              <a:t>AI Models: Google Gemini 1.5 Flash (Primary), Groq Cloud APIs (Secondary)</a:t>
-            </a:r>
-          </a:p>
-          <a:p>
-            <a:pPr/>
-            <a:r>
-              <a:t>PDF Engine: ReportLab layout flowables</a:t>
+            <a:pPr>
+              <a:defRPr sz="1400">
+                <a:solidFill>
+                  <a:srgbClr val="1A252C"/>
+                </a:solidFill>
+              </a:defRPr>
+            </a:pPr>
+            <a:r>
+              <a:t>Dynamic Time-Windows: Attendance check-in is restricted to configurable timing windows.</a:t>
+            </a:r>
+          </a:p>
+          <a:p>
+            <a:pPr>
+              <a:defRPr sz="1400">
+                <a:solidFill>
+                  <a:srgbClr val="1A252C"/>
+                </a:solidFill>
+              </a:defRPr>
+            </a:pPr>
+            <a:r>
+              <a:t>QR Token Checking: QR hashes change dynamically to prevent student code sharing.</a:t>
+            </a:r>
+          </a:p>
+          <a:p>
+            <a:pPr>
+              <a:defRPr sz="1400">
+                <a:solidFill>
+                  <a:srgbClr val="1A252C"/>
+                </a:solidFill>
+              </a:defRPr>
+            </a:pPr>
+            <a:r>
+              <a:t>GPS Geofencing: Calculates user distance against classroom coordinates (LPU block center).</a:t>
+            </a:r>
+          </a:p>
+          <a:p>
+            <a:pPr>
+              <a:defRPr sz="1400">
+                <a:solidFill>
+                  <a:srgbClr val="1A252C"/>
+                </a:solidFill>
+              </a:defRPr>
+            </a:pPr>
+            <a:r>
+              <a:t>Manual Override: HRDC staff can manually force logs, writing notes.</a:t>
             </a:r>
           </a:p>
         </p:txBody>

</xml_diff>

<commit_message>
Revert "Configure LPU HRDC Nexus training lifecycle platform, adding LangGraph pipelines, PWA manifests, and geofenced attendance"
This reverts commit becb46c400ed47dc012a85a4eb7fbd3b4da05b99.
</commit_message>
<xml_diff>
--- a/LPU_FDP_Presentation.pptx
+++ b/LPU_FDP_Presentation.pptx
@@ -22,7 +22,6 @@
     <p:sldId id="270" r:id="rId22"/>
     <p:sldId id="271" r:id="rId23"/>
     <p:sldId id="272" r:id="rId24"/>
-    <p:sldId id="273" r:id="rId25"/>
   </p:sldIdLst>
   <p:sldSz cx="9144000" cy="6858000" type="screen4x3"/>
   <p:notesSz cx="6858000" cy="9144000"/>
@@ -519,7 +518,7 @@
           <a:lstStyle/>
           <a:p>
             <a:r>
-              <a:t>Good morning members of the HRDC leadership panel. Today, we present LPU HRDC Nexus, an enterprise-grade AI-powered training lifecycle management platform designed to automate and digitize the complete training program pipeline.</a:t>
+              <a:t>Good morning members of the FDP evaluation panel. Today, we present the LPU Academic Copilot, a full-stack platform driven by a 10-agent orchestrator to automate the standard curriculum preparation workflow.</a:t>
             </a:r>
           </a:p>
         </p:txBody>
@@ -589,7 +588,7 @@
           <a:lstStyle/>
           <a:p>
             <a:r>
-              <a:t>Auto-grading saves faculty extensive evaluation time. The leaderboard fosters a healthy learning dynamic.</a:t>
+              <a:t>The database contains six main relational tables. The agent logs feed our front-end progress indicators, providing trace information to users in real-time.</a:t>
             </a:r>
           </a:p>
         </p:txBody>
@@ -659,7 +658,7 @@
           <a:lstStyle/>
           <a:p>
             <a:r>
-              <a:t>Nexus evaluates training return-on-investment (ROI) by assessing pre-post test score differences.</a:t>
+              <a:t>The key features include progress tracking, configuration customization, and automatic database fallbacks, rendering the platform robust.</a:t>
             </a:r>
           </a:p>
         </p:txBody>
@@ -729,7 +728,7 @@
           <a:lstStyle/>
           <a:p>
             <a:r>
-              <a:t>Certificates are issued automatically upon meeting attendance and assessment requirements.</a:t>
+              <a:t>For the evaluation, we demonstrate a complete flow using a sample Machine Learning syllabus. We register, upload, watch the log timeline, and download the output PDF.</a:t>
             </a:r>
           </a:p>
         </p:txBody>
@@ -799,7 +798,7 @@
           <a:lstStyle/>
           <a:p>
             <a:r>
-              <a:t>Nexus provides HRDC with a CRM module to log consulting contracts and client invoices.</a:t>
+              <a:t>Our metrics show a drastic improvement in efficiency, with 100% adherence to standard formatting requirements.</a:t>
             </a:r>
           </a:p>
         </p:txBody>
@@ -869,7 +868,7 @@
           <a:lstStyle/>
           <a:p>
             <a:r>
-              <a:t>PWA compatibility makes classroom check-ins faster. Users install it with one click.</a:t>
+              <a:t>In the future, we plan to connect this directly to LPU's LMS and automate lecture slide synthesis.</a:t>
             </a:r>
           </a:p>
         </p:txBody>
@@ -939,7 +938,7 @@
           <a:lstStyle/>
           <a:p>
             <a:r>
-              <a:t>Security is enforced at all levels. RLS ensures trainers only see their courses, and participants only see their profiles.</a:t>
+              <a:t>Security is maintained via RLS policies and CORS domain restrictions, while asynchronous execution keeps the app highly responsive.</a:t>
             </a:r>
           </a:p>
         </p:txBody>
@@ -1009,7 +1008,7 @@
           <a:lstStyle/>
           <a:p>
             <a:r>
-              <a:t>Our deployment pipeline is fully automated. Commits to the repository automatically redeploy the stack.</a:t>
+              <a:t>In conclusion, the LPU Academic Copilot shows how agentic workflows can transform administrative tasks into standard, audited outputs.</a:t>
             </a:r>
           </a:p>
         </p:txBody>
@@ -1079,77 +1078,7 @@
           <a:lstStyle/>
           <a:p>
             <a:r>
-              <a:t>Nexus consolidates attendance, evaluations, certificates, corporate CRM, and AI support.</a:t>
-            </a:r>
-          </a:p>
-        </p:txBody>
-      </p:sp>
-      <p:sp>
-        <p:nvSpPr>
-          <p:cNvPr id="4" name="Slide Number Placeholder 3"/>
-          <p:cNvSpPr>
-            <a:spLocks noGrp="1"/>
-          </p:cNvSpPr>
-          <p:nvPr>
-            <p:ph type="sldNum" idx="5" sz="quarter"/>
-          </p:nvPr>
-        </p:nvSpPr>
-        <p:spPr/>
-      </p:sp>
-    </p:spTree>
-  </p:cSld>
-  <p:clrMapOvr>
-    <a:masterClrMapping/>
-  </p:clrMapOvr>
-</p:notes>
-</file>
-
-<file path=ppt/notesSlides/notesSlide18.xml><?xml version="1.0" encoding="utf-8"?>
-<p:notes xmlns:a="http://schemas.openxmlformats.org/drawingml/2006/main" xmlns:p="http://schemas.openxmlformats.org/presentationml/2006/main" xmlns:r="http://schemas.openxmlformats.org/officeDocument/2006/relationships">
-  <p:cSld>
-    <p:spTree>
-      <p:nvGrpSpPr>
-        <p:cNvPr id="1" name=""/>
-        <p:cNvGrpSpPr/>
-        <p:nvPr/>
-      </p:nvGrpSpPr>
-      <p:grpSpPr>
-        <a:xfrm>
-          <a:off x="0" y="0"/>
-          <a:ext cx="0" cy="0"/>
-          <a:chOff x="0" y="0"/>
-          <a:chExt cx="0" cy="0"/>
-        </a:xfrm>
-      </p:grpSpPr>
-      <p:sp>
-        <p:nvSpPr>
-          <p:cNvPr id="2" name="Slide Image Placeholder 1"/>
-          <p:cNvSpPr>
-            <a:spLocks noGrp="1"/>
-          </p:cNvSpPr>
-          <p:nvPr>
-            <p:ph type="sldImg" idx="2"/>
-          </p:nvPr>
-        </p:nvSpPr>
-        <p:spPr/>
-      </p:sp>
-      <p:sp>
-        <p:nvSpPr>
-          <p:cNvPr id="3" name="Notes Placeholder 2"/>
-          <p:cNvSpPr>
-            <a:spLocks noGrp="1"/>
-          </p:cNvSpPr>
-          <p:nvPr>
-            <p:ph type="body" idx="3" sz="quarter"/>
-          </p:nvPr>
-        </p:nvSpPr>
-        <p:spPr/>
-        <p:txBody>
-          <a:bodyPr/>
-          <a:lstStyle/>
-          <a:p>
-            <a:r>
-              <a:t>Future iterations will include proctoring, payment portal gateways, and biometric device bindings.</a:t>
+              <a:t>Thank you for your time. I am open to any questions you may have.</a:t>
             </a:r>
           </a:p>
         </p:txBody>
@@ -1219,7 +1148,7 @@
           <a:lstStyle/>
           <a:p>
             <a:r>
-              <a:t>LPU HRDC conducts dozens of programmes annually. Nexus aims to provide a centralized hub for managing attendees, materials, grades, attendance, certificates, and corporate clients.</a:t>
+              <a:t>The primary problem is administrative overload. Faculty members spend over 8 hours per planning cycle on paperwork, taking away from direct student mentoring.</a:t>
             </a:r>
           </a:p>
         </p:txBody>
@@ -1289,7 +1218,7 @@
           <a:lstStyle/>
           <a:p>
             <a:r>
-              <a:t>Administrators spend over 15 hours per training cycle on manual documentation, attendance verification, scoring, and certificate compilation.</a:t>
+              <a:t>We wanted to leverage modern agentic workflows to build an automated assistant that serves as a quality-audited companion to faculty members.</a:t>
             </a:r>
           </a:p>
         </p:txBody>
@@ -1359,7 +1288,7 @@
           <a:lstStyle/>
           <a:p>
             <a:r>
-              <a:t>Our technology stack ensures security, speed, and standard compliance. The frontend runs React 19, and the backend leverages Python and pgvector.</a:t>
+              <a:t>Our objectives focus on automation, structuring, mapping, and compilation, delivering a complete packet in under 40 seconds.</a:t>
             </a:r>
           </a:p>
         </p:txBody>
@@ -1429,7 +1358,7 @@
           <a:lstStyle/>
           <a:p>
             <a:r>
-              <a:t>The architecture is built to be resilient and cloud-native, decoupling compute and storage services.</a:t>
+              <a:t>During deployment, we solved major real-world challenges, such as handling Render's IPv4 network limitations when connecting to Supabase's IPv6 databases, and fixing download authentication loops.</a:t>
             </a:r>
           </a:p>
         </p:txBody>
@@ -1499,7 +1428,7 @@
           <a:lstStyle/>
           <a:p>
             <a:r>
-              <a:t>The schema supports complex cascades. For safety, the SQLAlchemy setup automatically falls back to local SQLite if remote PostgreSQL is unreachable.</a:t>
+              <a:t>Our solution decoupling Next.js and FastAPI provides a seamless UI tracking timeline while running intensive multi-agent models in the background.</a:t>
             </a:r>
           </a:p>
         </p:txBody>
@@ -1569,7 +1498,7 @@
           <a:lstStyle/>
           <a:p>
             <a:r>
-              <a:t>By using LangGraph, we move away from simple chatbot completion towards specialized reasoning agents, ensuring higher accuracy and citation validity.</a:t>
+              <a:t>The system architecture is built for resiliency. We use the Supabase Connection Pooler over port 6543 to bypass Render network restrictions.</a:t>
             </a:r>
           </a:p>
         </p:txBody>
@@ -1639,7 +1568,7 @@
           <a:lstStyle/>
           <a:p>
             <a:r>
-              <a:t>The RAG pipeline provides contextual answering. The HNSW index ensures search response times under 50 milliseconds.</a:t>
+              <a:t>Each agent is specialized. By prompting them in a sequence, the output of the Planning Agent forms the context for the generation, mapping, and quality check agents.</a:t>
             </a:r>
           </a:p>
         </p:txBody>
@@ -1709,7 +1638,7 @@
           <a:lstStyle/>
           <a:p>
             <a:r>
-              <a:t>This geofenced QR check-in stops classroom proxies, locking logs to actual classroom boundaries.</a:t>
+              <a:t>We are using modern, fast frameworks. Google Gemini 1.5 Flash provides high reasoning speeds, and ReportLab enables dynamic PDF layouts.</a:t>
             </a:r>
           </a:p>
         </p:txBody>
@@ -4730,15 +4659,8 @@
           <a:bodyPr/>
           <a:lstStyle/>
           <a:p>
-            <a:pPr>
-              <a:defRPr b="1">
-                <a:solidFill>
-                  <a:srgbClr val="E77817"/>
-                </a:solidFill>
-              </a:defRPr>
-            </a:pPr>
-            <a:r>
-              <a:t>LPU HRDC Nexus</a:t>
+            <a:r>
+              <a:t>LPU Academic Copilot</a:t>
             </a:r>
           </a:p>
         </p:txBody>
@@ -4758,20 +4680,13 @@
           <a:bodyPr/>
           <a:lstStyle/>
           <a:p>
-            <a:pPr>
-              <a:defRPr>
-                <a:solidFill>
-                  <a:srgbClr val="1A252C"/>
-                </a:solidFill>
-              </a:defRPr>
-            </a:pPr>
-            <a:r>
-              <a:t>An AI-Powered Training Lifecycle Management Platform</a:t>
-            </a:r>
-          </a:p>
-          <a:p>
-            <a:r>
-              <a:t>Lovely Professional University (LPU) HRDC Leadership Capstone</a:t>
+            <a:r>
+              <a:t>Multi-Agent AI Platform for Faculty Workflow Automation</a:t>
+            </a:r>
+          </a:p>
+          <a:p>
+            <a:r>
+              <a:t>Lovely Professional University (LPU) FDP Capstone</a:t>
             </a:r>
           </a:p>
         </p:txBody>
@@ -4809,15 +4724,8 @@
           <a:bodyPr/>
           <a:lstStyle/>
           <a:p>
-            <a:pPr>
-              <a:defRPr b="1">
-                <a:solidFill>
-                  <a:srgbClr val="E77817"/>
-                </a:solidFill>
-              </a:defRPr>
-            </a:pPr>
-            <a:r>
-              <a:t>Assessments Module &amp; MCQ grading</a:t>
+            <a:r>
+              <a:t>Relational Database Design</a:t>
             </a:r>
           </a:p>
         </p:txBody>
@@ -4837,51 +4745,33 @@
           <a:bodyPr/>
           <a:lstStyle/>
           <a:p>
-            <a:pPr>
-              <a:defRPr sz="1400">
-                <a:solidFill>
-                  <a:srgbClr val="1A252C"/>
-                </a:solidFill>
-              </a:defRPr>
-            </a:pPr>
-            <a:r>
-              <a:t>Multi-format Tests: Supports MCQ, Subjective assignments, and Code submissions.</a:t>
-            </a:r>
-          </a:p>
-          <a:p>
-            <a:pPr>
-              <a:defRPr sz="1400">
-                <a:solidFill>
-                  <a:srgbClr val="1A252C"/>
-                </a:solidFill>
-              </a:defRPr>
-            </a:pPr>
-            <a:r>
-              <a:t>MCQ Auto Evaluation: Student MCQ sheets are graded instantly, saving trainer hours.</a:t>
-            </a:r>
-          </a:p>
-          <a:p>
-            <a:pPr>
-              <a:defRPr sz="1400">
-                <a:solidFill>
-                  <a:srgbClr val="1A252C"/>
-                </a:solidFill>
-              </a:defRPr>
-            </a:pPr>
-            <a:r>
-              <a:t>Project Submittals: Logs Title, Abstract, GitHub URL, and presentation slideshow links.</a:t>
-            </a:r>
-          </a:p>
-          <a:p>
-            <a:pPr>
-              <a:defRPr sz="1400">
-                <a:solidFill>
-                  <a:srgbClr val="1A252C"/>
-                </a:solidFill>
-              </a:defRPr>
-            </a:pPr>
-            <a:r>
-              <a:t>Gamified Leaderboard: Tracks class performance, displaying top participants.</a:t>
+            <a:pPr/>
+            <a:r>
+              <a:t>users: Stores synchronized authentication profiles.</a:t>
+            </a:r>
+          </a:p>
+          <a:p>
+            <a:pPr/>
+            <a:r>
+              <a:t>syllabi: Holds the parsed text, code, and PDF path parameters.</a:t>
+            </a:r>
+          </a:p>
+          <a:p>
+            <a:pPr/>
+            <a:r>
+              <a:t>generation_histories: Tracks processing and completion states.</a:t>
+            </a:r>
+          </a:p>
+          <a:p>
+            <a:pPr/>
+            <a:r>
+              <a:t>agent_execution_logs: Feeds the live timeline in the frontend.</a:t>
+            </a:r>
+          </a:p>
+          <a:p>
+            <a:pPr/>
+            <a:r>
+              <a:t>All tables use Cascade On Delete constraints for data integrity.</a:t>
             </a:r>
           </a:p>
         </p:txBody>
@@ -4919,15 +4809,8 @@
           <a:bodyPr/>
           <a:lstStyle/>
           <a:p>
-            <a:pPr>
-              <a:defRPr b="1">
-                <a:solidFill>
-                  <a:srgbClr val="E77817"/>
-                </a:solidFill>
-              </a:defRPr>
-            </a:pPr>
-            <a:r>
-              <a:t>Feedback Index &amp; Pre-Post surveys</a:t>
+            <a:r>
+              <a:t>Key Platform Features</a:t>
             </a:r>
           </a:p>
         </p:txBody>
@@ -4947,51 +4830,33 @@
           <a:bodyPr/>
           <a:lstStyle/>
           <a:p>
-            <a:pPr>
-              <a:defRPr sz="1400">
-                <a:solidFill>
-                  <a:srgbClr val="1A252C"/>
-                </a:solidFill>
-              </a:defRPr>
-            </a:pPr>
-            <a:r>
-              <a:t>Ratings System: Participants rate trainer, content, venue, and facilities (1 to 5 scale).</a:t>
-            </a:r>
-          </a:p>
-          <a:p>
-            <a:pPr>
-              <a:defRPr sz="1400">
-                <a:solidFill>
-                  <a:srgbClr val="1A252C"/>
-                </a:solidFill>
-              </a:defRPr>
-            </a:pPr>
-            <a:r>
-              <a:t>Competency Surveys: Tracks knowledge before and after programs to calculate gain percentages.</a:t>
-            </a:r>
-          </a:p>
-          <a:p>
-            <a:pPr>
-              <a:defRPr sz="1400">
-                <a:solidFill>
-                  <a:srgbClr val="1A252C"/>
-                </a:solidFill>
-              </a:defRPr>
-            </a:pPr>
-            <a:r>
-              <a:t>ROI index: Automatically computes organizational performance metrics.</a:t>
-            </a:r>
-          </a:p>
-          <a:p>
-            <a:pPr>
-              <a:defRPr sz="1400">
-                <a:solidFill>
-                  <a:srgbClr val="1A252C"/>
-                </a:solidFill>
-              </a:defRPr>
-            </a:pPr>
-            <a:r>
-              <a:t>Improvement Recommendations: Generates feedback trends summaries.</a:t>
+            <a:pPr/>
+            <a:r>
+              <a:t>Interactive Uploader: Simple drag &amp; drop interface for PDF files.</a:t>
+            </a:r>
+          </a:p>
+          <a:p>
+            <a:pPr/>
+            <a:r>
+              <a:t>Live Timeline Logs: Real-time progress updates directly from background workers.</a:t>
+            </a:r>
+          </a:p>
+          <a:p>
+            <a:pPr/>
+            <a:r>
+              <a:t>Calibration Settings: Fine-tune model parameters and faculty details.</a:t>
+            </a:r>
+          </a:p>
+          <a:p>
+            <a:pPr/>
+            <a:r>
+              <a:t>Public Downloads: Direct, secure downloads without header conflicts.</a:t>
+            </a:r>
+          </a:p>
+          <a:p>
+            <a:pPr/>
+            <a:r>
+              <a:t>Resilient DB Fallback: Gracefully routes to SQLite locally if remote PG is offline.</a:t>
             </a:r>
           </a:p>
         </p:txBody>
@@ -5029,15 +4894,8 @@
           <a:bodyPr/>
           <a:lstStyle/>
           <a:p>
-            <a:pPr>
-              <a:defRPr b="1">
-                <a:solidFill>
-                  <a:srgbClr val="E77817"/>
-                </a:solidFill>
-              </a:defRPr>
-            </a:pPr>
-            <a:r>
-              <a:t>Auto-Generated Digital Certificates</a:t>
+            <a:r>
+              <a:t>Application Demonstration Flow</a:t>
             </a:r>
           </a:p>
         </p:txBody>
@@ -5057,51 +4915,33 @@
           <a:bodyPr/>
           <a:lstStyle/>
           <a:p>
-            <a:pPr>
-              <a:defRPr sz="1400">
-                <a:solidFill>
-                  <a:srgbClr val="1A252C"/>
-                </a:solidFill>
-              </a:defRPr>
-            </a:pPr>
-            <a:r>
-              <a:t>ReportLab PDF Compilation: Dynamically compiles certificates with participant name and date.</a:t>
-            </a:r>
-          </a:p>
-          <a:p>
-            <a:pPr>
-              <a:defRPr sz="1400">
-                <a:solidFill>
-                  <a:srgbClr val="1A252C"/>
-                </a:solidFill>
-              </a:defRPr>
-            </a:pPr>
-            <a:r>
-              <a:t>QR Code Verification: Includes QR verification hash linking to public checker page.</a:t>
-            </a:r>
-          </a:p>
-          <a:p>
-            <a:pPr>
-              <a:defRPr sz="1400">
-                <a:solidFill>
-                  <a:srgbClr val="1A252C"/>
-                </a:solidFill>
-              </a:defRPr>
-            </a:pPr>
-            <a:r>
-              <a:t>Digital Signature: Signs certificate PDFs for authenticity.</a:t>
-            </a:r>
-          </a:p>
-          <a:p>
-            <a:pPr>
-              <a:defRPr sz="1400">
-                <a:solidFill>
-                  <a:srgbClr val="1A252C"/>
-                </a:solidFill>
-              </a:defRPr>
-            </a:pPr>
-            <a:r>
-              <a:t>Verification Search Page: Allows employers to verify certificate validity.</a:t>
+            <a:pPr/>
+            <a:r>
+              <a:t>Step 1: User signs up/in on the Vercel frontend portal.</a:t>
+            </a:r>
+          </a:p>
+          <a:p>
+            <a:pPr/>
+            <a:r>
+              <a:t>Step 2: Uploads a standard syllabus PDF (e.g. Machine Learning).</a:t>
+            </a:r>
+          </a:p>
+          <a:p>
+            <a:pPr/>
+            <a:r>
+              <a:t>Step 3: Trigger Multi-Agent Workflow triggers background tasks.</a:t>
+            </a:r>
+          </a:p>
+          <a:p>
+            <a:pPr/>
+            <a:r>
+              <a:t>Step 4: Status timelines trace agent outputs concurrently.</a:t>
+            </a:r>
+          </a:p>
+          <a:p>
+            <a:pPr/>
+            <a:r>
+              <a:t>Step 5: The final Course Pack PDF is downloaded with 1 click.</a:t>
             </a:r>
           </a:p>
         </p:txBody>
@@ -5139,15 +4979,8 @@
           <a:bodyPr/>
           <a:lstStyle/>
           <a:p>
-            <a:pPr>
-              <a:defRPr b="1">
-                <a:solidFill>
-                  <a:srgbClr val="E77817"/>
-                </a:solidFill>
-              </a:defRPr>
-            </a:pPr>
-            <a:r>
-              <a:t>Corporate CRM Contract &amp; Billing</a:t>
+            <a:r>
+              <a:t>Results &amp; Benefits</a:t>
             </a:r>
           </a:p>
         </p:txBody>
@@ -5167,51 +5000,27 @@
           <a:bodyPr/>
           <a:lstStyle/>
           <a:p>
-            <a:pPr>
-              <a:defRPr sz="1400">
-                <a:solidFill>
-                  <a:srgbClr val="1A252C"/>
-                </a:solidFill>
-              </a:defRPr>
-            </a:pPr>
-            <a:r>
-              <a:t>Clients registry: Catalog corporate contacts, phone numbers and companies.</a:t>
-            </a:r>
-          </a:p>
-          <a:p>
-            <a:pPr>
-              <a:defRPr sz="1400">
-                <a:solidFill>
-                  <a:srgbClr val="1A252C"/>
-                </a:solidFill>
-              </a:defRPr>
-            </a:pPr>
-            <a:r>
-              <a:t>Billing Invoices: Logs invoice details, contract URL and billing totals.</a:t>
-            </a:r>
-          </a:p>
-          <a:p>
-            <a:pPr>
-              <a:defRPr sz="1400">
-                <a:solidFill>
-                  <a:srgbClr val="1A252C"/>
-                </a:solidFill>
-              </a:defRPr>
-            </a:pPr>
-            <a:r>
-              <a:t>Payment Tracking: Manages invoice status tags (Paid, Pending, Cancelled).</a:t>
-            </a:r>
-          </a:p>
-          <a:p>
-            <a:pPr>
-              <a:defRPr sz="1400">
-                <a:solidFill>
-                  <a:srgbClr val="1A252C"/>
-                </a:solidFill>
-              </a:defRPr>
-            </a:pPr>
-            <a:r>
-              <a:t>Financial Dashboard: Displays revenue rollups on the homepage.</a:t>
+            <a:pPr/>
+            <a:r>
+              <a:t>Over 8 hours saved per course planning cycle.</a:t>
+            </a:r>
+          </a:p>
+          <a:p>
+            <a:pPr/>
+            <a:r>
+              <a:t>Ensures 100% standard formatting across university course packs.</a:t>
+            </a:r>
+          </a:p>
+          <a:p>
+            <a:pPr/>
+            <a:r>
+              <a:t>Objective grading: Bloom's Taxonomy cognitive weights are mapped uniformly.</a:t>
+            </a:r>
+          </a:p>
+          <a:p>
+            <a:pPr/>
+            <a:r>
+              <a:t>Immediate quality feedback allows faster curriculum iterations.</a:t>
             </a:r>
           </a:p>
         </p:txBody>
@@ -5249,15 +5058,8 @@
           <a:bodyPr/>
           <a:lstStyle/>
           <a:p>
-            <a:pPr>
-              <a:defRPr b="1">
-                <a:solidFill>
-                  <a:srgbClr val="E77817"/>
-                </a:solidFill>
-              </a:defRPr>
-            </a:pPr>
-            <a:r>
-              <a:t>Mobile Installable PWA Experience</a:t>
+            <a:r>
+              <a:t>Future Scope &amp; Enhancements</a:t>
             </a:r>
           </a:p>
         </p:txBody>
@@ -5277,51 +5079,27 @@
           <a:bodyPr/>
           <a:lstStyle/>
           <a:p>
-            <a:pPr>
-              <a:defRPr sz="1400">
-                <a:solidFill>
-                  <a:srgbClr val="1A252C"/>
-                </a:solidFill>
-              </a:defRPr>
-            </a:pPr>
-            <a:r>
-              <a:t>No App Store Required: Users install the app directly from browser options.</a:t>
-            </a:r>
-          </a:p>
-          <a:p>
-            <a:pPr>
-              <a:defRPr sz="1400">
-                <a:solidFill>
-                  <a:srgbClr val="1A252C"/>
-                </a:solidFill>
-              </a:defRPr>
-            </a:pPr>
-            <a:r>
-              <a:t>Stand-alone display: App opens in standalone window, hiding browser navigation.</a:t>
-            </a:r>
-          </a:p>
-          <a:p>
-            <a:pPr>
-              <a:defRPr sz="1400">
-                <a:solidFill>
-                  <a:srgbClr val="1A252C"/>
-                </a:solidFill>
-              </a:defRPr>
-            </a:pPr>
-            <a:r>
-              <a:t>Offline Caching: sw.js service worker caches essential pages and styles.</a:t>
-            </a:r>
-          </a:p>
-          <a:p>
-            <a:pPr>
-              <a:defRPr sz="1400">
-                <a:solidFill>
-                  <a:srgbClr val="1A252C"/>
-                </a:solidFill>
-              </a:defRPr>
-            </a:pPr>
-            <a:r>
-              <a:t>Responsive Layouts: Mobile, Tablet, and Desktop responsive CSS design tokens.</a:t>
+            <a:pPr/>
+            <a:r>
+              <a:t>Direct LPU LMS / UMS Integration: Push course packs to class groups instantly.</a:t>
+            </a:r>
+          </a:p>
+          <a:p>
+            <a:pPr/>
+            <a:r>
+              <a:t>AI Lecture Notes: Automatically generate slide decks and lecture notes for weekly plans.</a:t>
+            </a:r>
+          </a:p>
+          <a:p>
+            <a:pPr/>
+            <a:r>
+              <a:t>Syllabus Comparison: Cross-correlate multiple syllabi to identify gaps.</a:t>
+            </a:r>
+          </a:p>
+          <a:p>
+            <a:pPr/>
+            <a:r>
+              <a:t>OpenAI/Anthropic Engine integrations.</a:t>
             </a:r>
           </a:p>
         </p:txBody>
@@ -5359,15 +5137,8 @@
           <a:bodyPr/>
           <a:lstStyle/>
           <a:p>
-            <a:pPr>
-              <a:defRPr b="1">
-                <a:solidFill>
-                  <a:srgbClr val="E77817"/>
-                </a:solidFill>
-              </a:defRPr>
-            </a:pPr>
-            <a:r>
-              <a:t>Security &amp; OWASP Compliance</a:t>
+            <a:r>
+              <a:t>Security &amp; Performance Considerations</a:t>
             </a:r>
           </a:p>
         </p:txBody>
@@ -5387,51 +5158,27 @@
           <a:bodyPr/>
           <a:lstStyle/>
           <a:p>
-            <a:pPr>
-              <a:defRPr sz="1400">
-                <a:solidFill>
-                  <a:srgbClr val="1A252C"/>
-                </a:solidFill>
-              </a:defRPr>
-            </a:pPr>
-            <a:r>
-              <a:t>Row Level Security (RLS): Supabase table access checks protect student/financial files.</a:t>
-            </a:r>
-          </a:p>
-          <a:p>
-            <a:pPr>
-              <a:defRPr sz="1400">
-                <a:solidFill>
-                  <a:srgbClr val="1A252C"/>
-                </a:solidFill>
-              </a:defRPr>
-            </a:pPr>
-            <a:r>
-              <a:t>JWT Token validation: Endpoints verify authentication tokens before querying database.</a:t>
-            </a:r>
-          </a:p>
-          <a:p>
-            <a:pPr>
-              <a:defRPr sz="1400">
-                <a:solidFill>
-                  <a:srgbClr val="1A252C"/>
-                </a:solidFill>
-              </a:defRPr>
-            </a:pPr>
-            <a:r>
-              <a:t>Input Validation: Pydantic schemas and Zod constraints sanitize data entry.</a:t>
-            </a:r>
-          </a:p>
-          <a:p>
-            <a:pPr>
-              <a:defRPr sz="1400">
-                <a:solidFill>
-                  <a:srgbClr val="1A252C"/>
-                </a:solidFill>
-              </a:defRPr>
-            </a:pPr>
-            <a:r>
-              <a:t>Docker isolation: Containers prevent local file-system vulnerabilities.</a:t>
+            <a:pPr/>
+            <a:r>
+              <a:t>Data Isolation: Users can only see and manage their own syllabus histories.</a:t>
+            </a:r>
+          </a:p>
+          <a:p>
+            <a:pPr/>
+            <a:r>
+              <a:t>CORS Protection: Domain locks prevent cross-origin scripting hacks.</a:t>
+            </a:r>
+          </a:p>
+          <a:p>
+            <a:pPr/>
+            <a:r>
+              <a:t>Async Background Workers: Keeps the API gateway responsive during heavy LLM calls.</a:t>
+            </a:r>
+          </a:p>
+          <a:p>
+            <a:pPr/>
+            <a:r>
+              <a:t>Sanitized Database URLs: Dynamic filters prevent credential leaks in trace logs.</a:t>
             </a:r>
           </a:p>
         </p:txBody>
@@ -5469,15 +5216,8 @@
           <a:bodyPr/>
           <a:lstStyle/>
           <a:p>
-            <a:pPr>
-              <a:defRPr b="1">
-                <a:solidFill>
-                  <a:srgbClr val="E77817"/>
-                </a:solidFill>
-              </a:defRPr>
-            </a:pPr>
-            <a:r>
-              <a:t>Cloud-Native Deployment Pipeline</a:t>
+            <a:r>
+              <a:t>Conclusion</a:t>
             </a:r>
           </a:p>
         </p:txBody>
@@ -5497,51 +5237,27 @@
           <a:bodyPr/>
           <a:lstStyle/>
           <a:p>
-            <a:pPr>
-              <a:defRPr sz="1400">
-                <a:solidFill>
-                  <a:srgbClr val="1A252C"/>
-                </a:solidFill>
-              </a:defRPr>
-            </a:pPr>
-            <a:r>
-              <a:t>Vercel (Frontend): Continuous integration build linked to GitHub repo branches.</a:t>
-            </a:r>
-          </a:p>
-          <a:p>
-            <a:pPr>
-              <a:defRPr sz="1400">
-                <a:solidFill>
-                  <a:srgbClr val="1A252C"/>
-                </a:solidFill>
-              </a:defRPr>
-            </a:pPr>
-            <a:r>
-              <a:t>Render (Backend): Containerized FastAPI Docker service auto-building on git push.</a:t>
-            </a:r>
-          </a:p>
-          <a:p>
-            <a:pPr>
-              <a:defRPr sz="1400">
-                <a:solidFill>
-                  <a:srgbClr val="1A252C"/>
-                </a:solidFill>
-              </a:defRPr>
-            </a:pPr>
-            <a:r>
-              <a:t>Supabase Cloud: Hosts Postgres, Auth, pgvector, and Object storage.</a:t>
-            </a:r>
-          </a:p>
-          <a:p>
-            <a:pPr>
-              <a:defRPr sz="1400">
-                <a:solidFill>
-                  <a:srgbClr val="1A252C"/>
-                </a:solidFill>
-              </a:defRPr>
-            </a:pPr>
-            <a:r>
-              <a:t>Alembic DB migrations: Triggers migrations automatically during start commands.</a:t>
+            <a:pPr/>
+            <a:r>
+              <a:t>Decoupled multi-agent architecture successfully validated in production.</a:t>
+            </a:r>
+          </a:p>
+          <a:p>
+            <a:pPr/>
+            <a:r>
+              <a:t>Delivers a complete, audited course package dynamically.</a:t>
+            </a:r>
+          </a:p>
+          <a:p>
+            <a:pPr/>
+            <a:r>
+              <a:t>Bypasses complex deployment and database connection conflicts.</a:t>
+            </a:r>
+          </a:p>
+          <a:p>
+            <a:pPr/>
+            <a:r>
+              <a:t>Innovative solution to elevate institutional planning efficiency.</a:t>
             </a:r>
           </a:p>
         </p:txBody>
@@ -5571,197 +5287,42 @@
             <a:spLocks noGrp="1"/>
           </p:cNvSpPr>
           <p:nvPr>
-            <p:ph type="title"/>
-          </p:nvPr>
-        </p:nvSpPr>
-        <p:spPr/>
-        <p:txBody>
-          <a:bodyPr/>
-          <a:lstStyle/>
-          <a:p>
-            <a:pPr>
-              <a:defRPr b="1">
-                <a:solidFill>
-                  <a:srgbClr val="E77817"/>
-                </a:solidFill>
-              </a:defRPr>
-            </a:pPr>
-            <a:r>
-              <a:t>Institutional Benefits &amp; Key Results</a:t>
-            </a:r>
-          </a:p>
-        </p:txBody>
-      </p:sp>
-      <p:sp>
-        <p:nvSpPr>
-          <p:cNvPr id="3" name="Content Placeholder 2"/>
-          <p:cNvSpPr>
-            <a:spLocks noGrp="1"/>
-          </p:cNvSpPr>
-          <p:nvPr>
-            <p:ph idx="1"/>
-          </p:nvPr>
-        </p:nvSpPr>
-        <p:spPr/>
-        <p:txBody>
-          <a:bodyPr/>
-          <a:lstStyle/>
-          <a:p>
-            <a:pPr>
-              <a:defRPr sz="1400">
-                <a:solidFill>
-                  <a:srgbClr val="1A252C"/>
-                </a:solidFill>
-              </a:defRPr>
-            </a:pPr>
-            <a:r>
-              <a:t>Time Saving: Reduces administrative documentation hours by 85% per course cycle.</a:t>
-            </a:r>
-          </a:p>
-          <a:p>
-            <a:pPr>
-              <a:defRPr sz="1400">
-                <a:solidFill>
-                  <a:srgbClr val="1A252C"/>
-                </a:solidFill>
-              </a:defRPr>
-            </a:pPr>
-            <a:r>
-              <a:t>Accuracy: Geofencing eliminates attendance proxies and certificate fraud.</a:t>
-            </a:r>
-          </a:p>
-          <a:p>
-            <a:pPr>
-              <a:defRPr sz="1400">
-                <a:solidFill>
-                  <a:srgbClr val="1A252C"/>
-                </a:solidFill>
-              </a:defRPr>
-            </a:pPr>
-            <a:r>
-              <a:t>Knowledge Retrieval: LangGraph/pgvector lets staff query training details instantly.</a:t>
-            </a:r>
-          </a:p>
-          <a:p>
-            <a:pPr>
-              <a:defRPr sz="1400">
-                <a:solidFill>
-                  <a:srgbClr val="1A252C"/>
-                </a:solidFill>
-              </a:defRPr>
-            </a:pPr>
-            <a:r>
-              <a:t>Agility: Replaces five legacy systems with a single consolidated web workspace.</a:t>
-            </a:r>
-          </a:p>
-        </p:txBody>
-      </p:sp>
-    </p:spTree>
-  </p:cSld>
-  <p:clrMapOvr>
-    <a:masterClrMapping/>
-  </p:clrMapOvr>
-</p:sld>
-</file>
-
-<file path=ppt/slides/slide18.xml><?xml version="1.0" encoding="utf-8"?>
-<p:sld xmlns:a="http://schemas.openxmlformats.org/drawingml/2006/main" xmlns:p="http://schemas.openxmlformats.org/presentationml/2006/main" xmlns:r="http://schemas.openxmlformats.org/officeDocument/2006/relationships">
-  <p:cSld>
-    <p:spTree>
-      <p:nvGrpSpPr>
-        <p:cNvPr id="1" name=""/>
-        <p:cNvGrpSpPr/>
-        <p:nvPr/>
-      </p:nvGrpSpPr>
-      <p:grpSpPr/>
-      <p:sp>
-        <p:nvSpPr>
-          <p:cNvPr id="2" name="Title 1"/>
-          <p:cNvSpPr>
-            <a:spLocks noGrp="1"/>
-          </p:cNvSpPr>
-          <p:nvPr>
-            <p:ph type="title"/>
-          </p:nvPr>
-        </p:nvSpPr>
-        <p:spPr/>
-        <p:txBody>
-          <a:bodyPr/>
-          <a:lstStyle/>
-          <a:p>
-            <a:pPr>
-              <a:defRPr b="1">
-                <a:solidFill>
-                  <a:srgbClr val="E77817"/>
-                </a:solidFill>
-              </a:defRPr>
-            </a:pPr>
-            <a:r>
-              <a:t>Future Scope &amp; Platform Roadmap</a:t>
-            </a:r>
-          </a:p>
-        </p:txBody>
-      </p:sp>
-      <p:sp>
-        <p:nvSpPr>
-          <p:cNvPr id="3" name="Content Placeholder 2"/>
-          <p:cNvSpPr>
-            <a:spLocks noGrp="1"/>
-          </p:cNvSpPr>
-          <p:nvPr>
-            <p:ph idx="1"/>
-          </p:nvPr>
-        </p:nvSpPr>
-        <p:spPr/>
-        <p:txBody>
-          <a:bodyPr/>
-          <a:lstStyle/>
-          <a:p>
-            <a:pPr>
-              <a:defRPr sz="1400">
-                <a:solidFill>
-                  <a:srgbClr val="1A252C"/>
-                </a:solidFill>
-              </a:defRPr>
-            </a:pPr>
-            <a:r>
-              <a:t>Biometric Attendance Integration: Connect face/fingerprint scanners directly via IoT APIs.</a:t>
-            </a:r>
-          </a:p>
-          <a:p>
-            <a:pPr>
-              <a:defRPr sz="1400">
-                <a:solidFill>
-                  <a:srgbClr val="1A252C"/>
-                </a:solidFill>
-              </a:defRPr>
-            </a:pPr>
-            <a:r>
-              <a:t>AI Proctoring: Enable webcam analysis during subjective assessment submissions.</a:t>
-            </a:r>
-          </a:p>
-          <a:p>
-            <a:pPr>
-              <a:defRPr sz="1400">
-                <a:solidFill>
-                  <a:srgbClr val="1A252C"/>
-                </a:solidFill>
-              </a:defRPr>
-            </a:pPr>
-            <a:r>
-              <a:t>External Vendor API integration: Expose training courses to corporate job boards.</a:t>
-            </a:r>
-          </a:p>
-          <a:p>
-            <a:pPr>
-              <a:defRPr sz="1400">
-                <a:solidFill>
-                  <a:srgbClr val="1A252C"/>
-                </a:solidFill>
-              </a:defRPr>
-            </a:pPr>
-            <a:r>
-              <a:t>Automated Email Reminders: Trigger reminders via Sengrid/SMTP integration.</a:t>
+            <p:ph type="ctrTitle"/>
+          </p:nvPr>
+        </p:nvSpPr>
+        <p:spPr/>
+        <p:txBody>
+          <a:bodyPr/>
+          <a:lstStyle/>
+          <a:p>
+            <a:r>
+              <a:t>Thank You</a:t>
+            </a:r>
+          </a:p>
+        </p:txBody>
+      </p:sp>
+      <p:sp>
+        <p:nvSpPr>
+          <p:cNvPr id="3" name="Subtitle 2"/>
+          <p:cNvSpPr>
+            <a:spLocks noGrp="1"/>
+          </p:cNvSpPr>
+          <p:nvPr>
+            <p:ph type="subTitle" idx="1"/>
+          </p:nvPr>
+        </p:nvSpPr>
+        <p:spPr/>
+        <p:txBody>
+          <a:bodyPr/>
+          <a:lstStyle/>
+          <a:p>
+            <a:r>
+              <a:t>Lovely Professional University (LPU)</a:t>
+            </a:r>
+          </a:p>
+          <a:p>
+            <a:r>
+              <a:t>FDP Final Evaluation - Q&amp;A Session</a:t>
             </a:r>
           </a:p>
         </p:txBody>
@@ -5799,15 +5360,8 @@
           <a:bodyPr/>
           <a:lstStyle/>
           <a:p>
-            <a:pPr>
-              <a:defRPr b="1">
-                <a:solidFill>
-                  <a:srgbClr val="E77817"/>
-                </a:solidFill>
-              </a:defRPr>
-            </a:pPr>
-            <a:r>
-              <a:t>Objectives of LPU HRDC Nexus</a:t>
+            <a:r>
+              <a:t>Problem Statement</a:t>
             </a:r>
           </a:p>
         </p:txBody>
@@ -5827,63 +5381,27 @@
           <a:bodyPr/>
           <a:lstStyle/>
           <a:p>
-            <a:pPr>
-              <a:defRPr sz="1400">
-                <a:solidFill>
-                  <a:srgbClr val="1A252C"/>
-                </a:solidFill>
-              </a:defRPr>
-            </a:pPr>
-            <a:r>
-              <a:t>Manage the complete lifecycle of faculty development (FDPs), workshops, refresher courses, and orientations.</a:t>
-            </a:r>
-          </a:p>
-          <a:p>
-            <a:pPr>
-              <a:defRPr sz="1400">
-                <a:solidFill>
-                  <a:srgbClr val="1A252C"/>
-                </a:solidFill>
-              </a:defRPr>
-            </a:pPr>
-            <a:r>
-              <a:t>Automate classroom check-in via geofenced QR Code scanning.</a:t>
-            </a:r>
-          </a:p>
-          <a:p>
-            <a:pPr>
-              <a:defRPr sz="1400">
-                <a:solidFill>
-                  <a:srgbClr val="1A252C"/>
-                </a:solidFill>
-              </a:defRPr>
-            </a:pPr>
-            <a:r>
-              <a:t>Provide multi-format academic evaluations (MCQ, Subjective, Coding, Project Submissions).</a:t>
-            </a:r>
-          </a:p>
-          <a:p>
-            <a:pPr>
-              <a:defRPr sz="1400">
-                <a:solidFill>
-                  <a:srgbClr val="1A252C"/>
-                </a:solidFill>
-              </a:defRPr>
-            </a:pPr>
-            <a:r>
-              <a:t>Integrate digital certificate compilation with QR verification page and digital signatures.</a:t>
-            </a:r>
-          </a:p>
-          <a:p>
-            <a:pPr>
-              <a:defRPr sz="1400">
-                <a:solidFill>
-                  <a:srgbClr val="1A252C"/>
-                </a:solidFill>
-              </a:defRPr>
-            </a:pPr>
-            <a:r>
-              <a:t>Establish a corporate training module to log client invoices and contract agreements.</a:t>
+            <a:pPr/>
+            <a:r>
+              <a:t>Faculty spend significant hours manually drafting weekly delivery schedules.</a:t>
+            </a:r>
+          </a:p>
+          <a:p>
+            <a:pPr/>
+            <a:r>
+              <a:t>Designing assignments and quiz banks with correct answers is tedious and error-prone.</a:t>
+            </a:r>
+          </a:p>
+          <a:p>
+            <a:pPr/>
+            <a:r>
+              <a:t>Reviewing exam questions manually for cognitive weight (Bloom's Taxonomy) is highly subjective.</a:t>
+            </a:r>
+          </a:p>
+          <a:p>
+            <a:pPr/>
+            <a:r>
+              <a:t>Verifying syllabus compliance takes multiple iteration reviews, causing process delays.</a:t>
             </a:r>
           </a:p>
         </p:txBody>
@@ -5921,15 +5439,8 @@
           <a:bodyPr/>
           <a:lstStyle/>
           <a:p>
-            <a:pPr>
-              <a:defRPr b="1">
-                <a:solidFill>
-                  <a:srgbClr val="E77817"/>
-                </a:solidFill>
-              </a:defRPr>
-            </a:pPr>
-            <a:r>
-              <a:t>Problem Statement &amp; Existing Challenges</a:t>
+            <a:r>
+              <a:t>Motivation</a:t>
             </a:r>
           </a:p>
         </p:txBody>
@@ -5949,51 +5460,27 @@
           <a:bodyPr/>
           <a:lstStyle/>
           <a:p>
-            <a:pPr>
-              <a:defRPr sz="1400">
-                <a:solidFill>
-                  <a:srgbClr val="1A252C"/>
-                </a:solidFill>
-              </a:defRPr>
-            </a:pPr>
-            <a:r>
-              <a:t>Paper-based attendance is slow, prone to proxy inputs, and lacks geographical verification.</a:t>
-            </a:r>
-          </a:p>
-          <a:p>
-            <a:pPr>
-              <a:defRPr sz="1400">
-                <a:solidFill>
-                  <a:srgbClr val="1A252C"/>
-                </a:solidFill>
-              </a:defRPr>
-            </a:pPr>
-            <a:r>
-              <a:t>Drafting quizzes, grading projects, and compiling certificates manually consumes extensive administrative time.</a:t>
-            </a:r>
-          </a:p>
-          <a:p>
-            <a:pPr>
-              <a:defRPr sz="1400">
-                <a:solidFill>
-                  <a:srgbClr val="1A252C"/>
-                </a:solidFill>
-              </a:defRPr>
-            </a:pPr>
-            <a:r>
-              <a:t>Syllabus files and lecture documents exist as scattered files, making knowledge retrieval difficult.</a:t>
-            </a:r>
-          </a:p>
-          <a:p>
-            <a:pPr>
-              <a:defRPr sz="1400">
-                <a:solidFill>
-                  <a:srgbClr val="1A252C"/>
-                </a:solidFill>
-              </a:defRPr>
-            </a:pPr>
-            <a:r>
-              <a:t>Tracking corporate revenue, contracts, and clients invoices is managed in disconnected spreadsheets.</a:t>
+            <a:pPr/>
+            <a:r>
+              <a:t>Empower lovely faculty members by automating repetitive documentation.</a:t>
+            </a:r>
+          </a:p>
+          <a:p>
+            <a:pPr/>
+            <a:r>
+              <a:t>Maintain absolute standardization across academic packages.</a:t>
+            </a:r>
+          </a:p>
+          <a:p>
+            <a:pPr/>
+            <a:r>
+              <a:t>Provide objective, automated feedback on curriculum compliance prior to class delivery.</a:t>
+            </a:r>
+          </a:p>
+          <a:p>
+            <a:pPr/>
+            <a:r>
+              <a:t>Accelerate institutional agility in resource compilation.</a:t>
             </a:r>
           </a:p>
         </p:txBody>
@@ -6031,15 +5518,8 @@
           <a:bodyPr/>
           <a:lstStyle/>
           <a:p>
-            <a:pPr>
-              <a:defRPr b="1">
-                <a:solidFill>
-                  <a:srgbClr val="E77817"/>
-                </a:solidFill>
-              </a:defRPr>
-            </a:pPr>
-            <a:r>
-              <a:t>Enterprise-Grade Technology Stack</a:t>
+            <a:r>
+              <a:t>Objectives</a:t>
             </a:r>
           </a:p>
         </p:txBody>
@@ -6059,51 +5539,33 @@
           <a:bodyPr/>
           <a:lstStyle/>
           <a:p>
-            <a:pPr>
-              <a:defRPr sz="1400">
-                <a:solidFill>
-                  <a:srgbClr val="1A252C"/>
-                </a:solidFill>
-              </a:defRPr>
-            </a:pPr>
-            <a:r>
-              <a:t>Frontend: Next.js 15 (App Router), React 19, TypeScript, TailwindCSS, Framer Motion.</a:t>
-            </a:r>
-          </a:p>
-          <a:p>
-            <a:pPr>
-              <a:defRPr sz="1400">
-                <a:solidFill>
-                  <a:srgbClr val="1A252C"/>
-                </a:solidFill>
-              </a:defRPr>
-            </a:pPr>
-            <a:r>
-              <a:t>Backend: FastAPI (Python 3.12 ASGI), SQLAlchemy ORM core database logic.</a:t>
-            </a:r>
-          </a:p>
-          <a:p>
-            <a:pPr>
-              <a:defRPr sz="1400">
-                <a:solidFill>
-                  <a:srgbClr val="1A252C"/>
-                </a:solidFill>
-              </a:defRPr>
-            </a:pPr>
-            <a:r>
-              <a:t>Storage &amp; Auth: Supabase PostgreSQL database, Object Storage buckets, and JWT authentication.</a:t>
-            </a:r>
-          </a:p>
-          <a:p>
-            <a:pPr>
-              <a:defRPr sz="1400">
-                <a:solidFill>
-                  <a:srgbClr val="1A252C"/>
-                </a:solidFill>
-              </a:defRPr>
-            </a:pPr>
-            <a:r>
-              <a:t>AI Reasoning &amp; Indexing: Groq Cloud API LLMs, LangGraph multi-agent orchestration, and pgvector HNSW database indexes.</a:t>
+            <a:pPr/>
+            <a:r>
+              <a:t>Parse standard syllabus PDF files dynamically.</a:t>
+            </a:r>
+          </a:p>
+          <a:p>
+            <a:pPr/>
+            <a:r>
+              <a:t>Orchestrate a 10-Agent pipeline in a concurrent/dependent sequence.</a:t>
+            </a:r>
+          </a:p>
+          <a:p>
+            <a:pPr/>
+            <a:r>
+              <a:t>Generate structured lecture schedules, progressive assignments, and 20 MCQs.</a:t>
+            </a:r>
+          </a:p>
+          <a:p>
+            <a:pPr/>
+            <a:r>
+              <a:t>Conduct objective Bloom's cognitive mapping and Course Outcome correlation.</a:t>
+            </a:r>
+          </a:p>
+          <a:p>
+            <a:pPr/>
+            <a:r>
+              <a:t>Output a publication-ready Course Package PDF containing all reviewed deliverables.</a:t>
             </a:r>
           </a:p>
         </p:txBody>
@@ -6141,15 +5603,8 @@
           <a:bodyPr/>
           <a:lstStyle/>
           <a:p>
-            <a:pPr>
-              <a:defRPr b="1">
-                <a:solidFill>
-                  <a:srgbClr val="E77817"/>
-                </a:solidFill>
-              </a:defRPr>
-            </a:pPr>
-            <a:r>
-              <a:t>System Architecture Overview</a:t>
+            <a:r>
+              <a:t>Existing Challenges in AI Document Synthesis</a:t>
             </a:r>
           </a:p>
         </p:txBody>
@@ -6169,51 +5624,27 @@
           <a:bodyPr/>
           <a:lstStyle/>
           <a:p>
-            <a:pPr>
-              <a:defRPr sz="1400">
-                <a:solidFill>
-                  <a:srgbClr val="1A252C"/>
-                </a:solidFill>
-              </a:defRPr>
-            </a:pPr>
-            <a:r>
-              <a:t>Decoupled Layout: Next.js frontend deployed to Vercel, FastAPI backend deployed to Render.</a:t>
-            </a:r>
-          </a:p>
-          <a:p>
-            <a:pPr>
-              <a:defRPr sz="1400">
-                <a:solidFill>
-                  <a:srgbClr val="1A252C"/>
-                </a:solidFill>
-              </a:defRPr>
-            </a:pPr>
-            <a:r>
-              <a:t>Database Connection Pooler: Supabase pooler over port 6543 handles high concurrent queries.</a:t>
-            </a:r>
-          </a:p>
-          <a:p>
-            <a:pPr>
-              <a:defRPr sz="1400">
-                <a:solidFill>
-                  <a:srgbClr val="1A252C"/>
-                </a:solidFill>
-              </a:defRPr>
-            </a:pPr>
-            <a:r>
-              <a:t>Asynchronous Pipeline: Large documents parsing and pgvector RAG indexing run in background threads.</a:t>
-            </a:r>
-          </a:p>
-          <a:p>
-            <a:pPr>
-              <a:defRPr sz="1400">
-                <a:solidFill>
-                  <a:srgbClr val="1A252C"/>
-                </a:solidFill>
-              </a:defRPr>
-            </a:pPr>
-            <a:r>
-              <a:t>PWA Standalone: Installable directly from the browser with cached offline pages.</a:t>
+            <a:pPr/>
+            <a:r>
+              <a:t>Invalid Model Names: Out-of-date model identifiers cause live API crashes.</a:t>
+            </a:r>
+          </a:p>
+          <a:p>
+            <a:pPr/>
+            <a:r>
+              <a:t>DNS &amp; Network Barriers: Direct PostgreSQL IPv6 calls fail inside Render's IPv4 VMs.</a:t>
+            </a:r>
+          </a:p>
+          <a:p>
+            <a:pPr/>
+            <a:r>
+              <a:t>Query Param Incompatibilities: Unused parameters (like pgbouncer) crash DB drivers.</a:t>
+            </a:r>
+          </a:p>
+          <a:p>
+            <a:pPr/>
+            <a:r>
+              <a:t>Download Authentication Conflicts: Browser file downloads lack JWT bearer headers.</a:t>
             </a:r>
           </a:p>
         </p:txBody>
@@ -6251,15 +5682,8 @@
           <a:bodyPr/>
           <a:lstStyle/>
           <a:p>
-            <a:pPr>
-              <a:defRPr b="1">
-                <a:solidFill>
-                  <a:srgbClr val="E77817"/>
-                </a:solidFill>
-              </a:defRPr>
-            </a:pPr>
-            <a:r>
-              <a:t>PostgreSQL Relational DB Design</a:t>
+            <a:r>
+              <a:t>Proposed Solution</a:t>
             </a:r>
           </a:p>
         </p:txBody>
@@ -6279,51 +5703,33 @@
           <a:bodyPr/>
           <a:lstStyle/>
           <a:p>
-            <a:pPr>
-              <a:defRPr sz="1400">
-                <a:solidFill>
-                  <a:srgbClr val="1A252C"/>
-                </a:solidFill>
-              </a:defRPr>
-            </a:pPr>
-            <a:r>
-              <a:t>users &amp; profiles: Synchronized roles mapping (Admin, Staff, Trainer, Participant).</a:t>
-            </a:r>
-          </a:p>
-          <a:p>
-            <a:pPr>
-              <a:defRPr sz="1400">
-                <a:solidFill>
-                  <a:srgbClr val="1A252C"/>
-                </a:solidFill>
-              </a:defRPr>
-            </a:pPr>
-            <a:r>
-              <a:t>programmes &amp; sessions: Relational training structures and dynamic timetables.</a:t>
-            </a:r>
-          </a:p>
-          <a:p>
-            <a:pPr>
-              <a:defRPr sz="1400">
-                <a:solidFill>
-                  <a:srgbClr val="1A252C"/>
-                </a:solidFill>
-              </a:defRPr>
-            </a:pPr>
-            <a:r>
-              <a:t>attendance: Logs location coordinates, timestamps, and override justifications.</a:t>
-            </a:r>
-          </a:p>
-          <a:p>
-            <a:pPr>
-              <a:defRPr sz="1400">
-                <a:solidFill>
-                  <a:srgbClr val="1A252C"/>
-                </a:solidFill>
-              </a:defRPr>
-            </a:pPr>
-            <a:r>
-              <a:t>corporate_contracts: Tracks corporate consulting client invoices and billings.</a:t>
+            <a:pPr/>
+            <a:r>
+              <a:t>Full-stack web application linking Next.js 15 and FastAPI.</a:t>
+            </a:r>
+          </a:p>
+          <a:p>
+            <a:pPr/>
+            <a:r>
+              <a:t>State-of-the-art Google Gemini 1.5 Flash API reasoning models.</a:t>
+            </a:r>
+          </a:p>
+          <a:p>
+            <a:pPr/>
+            <a:r>
+              <a:t>An asynchronous 10-node agent orchestrator running in background threads.</a:t>
+            </a:r>
+          </a:p>
+          <a:p>
+            <a:pPr/>
+            <a:r>
+              <a:t>Supabase PostgreSQL and Object Storage database backend.</a:t>
+            </a:r>
+          </a:p>
+          <a:p>
+            <a:pPr/>
+            <a:r>
+              <a:t>CORS-compliant and authenticated APIs with public token-less download streams.</a:t>
             </a:r>
           </a:p>
         </p:txBody>
@@ -6361,15 +5767,8 @@
           <a:bodyPr/>
           <a:lstStyle/>
           <a:p>
-            <a:pPr>
-              <a:defRPr b="1">
-                <a:solidFill>
-                  <a:srgbClr val="E77817"/>
-                </a:solidFill>
-              </a:defRPr>
-            </a:pPr>
-            <a:r>
-              <a:t>LangGraph Multi-Agent reasoning Engine</a:t>
+            <a:r>
+              <a:t>System Architecture &amp; Data Flows</a:t>
             </a:r>
           </a:p>
         </p:txBody>
@@ -6389,63 +5788,27 @@
           <a:bodyPr/>
           <a:lstStyle/>
           <a:p>
-            <a:pPr>
-              <a:defRPr sz="1400">
-                <a:solidFill>
-                  <a:srgbClr val="1A252C"/>
-                </a:solidFill>
-              </a:defRPr>
-            </a:pPr>
-            <a:r>
-              <a:t>Intent Classification: Detects if the user query is about attendance, programs, docs, or analytics.</a:t>
-            </a:r>
-          </a:p>
-          <a:p>
-            <a:pPr>
-              <a:defRPr sz="1400">
-                <a:solidFill>
-                  <a:srgbClr val="1A252C"/>
-                </a:solidFill>
-              </a:defRPr>
-            </a:pPr>
-            <a:r>
-              <a:t>Routing Node: Dynamically dispatches task to designated agent.</a:t>
-            </a:r>
-          </a:p>
-          <a:p>
-            <a:pPr>
-              <a:defRPr sz="1400">
-                <a:solidFill>
-                  <a:srgbClr val="1A252C"/>
-                </a:solidFill>
-              </a:defRPr>
-            </a:pPr>
-            <a:r>
-              <a:t>Specialized Agents: Attendance Agent, Programme Agent, RAG Document Agent, Analytics Agent.</a:t>
-            </a:r>
-          </a:p>
-          <a:p>
-            <a:pPr>
-              <a:defRPr sz="1400">
-                <a:solidFill>
-                  <a:srgbClr val="1A252C"/>
-                </a:solidFill>
-              </a:defRPr>
-            </a:pPr>
-            <a:r>
-              <a:t>Validation Node: Cross-checks output facts against DB records to prevent hallucination.</a:t>
-            </a:r>
-          </a:p>
-          <a:p>
-            <a:pPr>
-              <a:defRPr sz="1400">
-                <a:solidFill>
-                  <a:srgbClr val="1A252C"/>
-                </a:solidFill>
-              </a:defRPr>
-            </a:pPr>
-            <a:r>
-              <a:t>Response Synthesis: Groq LLM drafts final cited response.</a:t>
+            <a:pPr/>
+            <a:r>
+              <a:t>Frontend: Next.js 15, TypeScript, Tailwind CSS, and Supabase client-side Auth.</a:t>
+            </a:r>
+          </a:p>
+          <a:p>
+            <a:pPr/>
+            <a:r>
+              <a:t>Backend: FastAPI (Python 3.12/3.14) serving REST APIs and managing Alembic migrations.</a:t>
+            </a:r>
+          </a:p>
+          <a:p>
+            <a:pPr/>
+            <a:r>
+              <a:t>Database Connection: Powered by Supabase Connection Pooler (Port 6543) resolving to IPv4.</a:t>
+            </a:r>
+          </a:p>
+          <a:p>
+            <a:pPr/>
+            <a:r>
+              <a:t>Authentication: Supabase JWT validation inside FastAPI dependencies.</a:t>
             </a:r>
           </a:p>
         </p:txBody>
@@ -6483,15 +5846,8 @@
           <a:bodyPr/>
           <a:lstStyle/>
           <a:p>
-            <a:pPr>
-              <a:defRPr b="1">
-                <a:solidFill>
-                  <a:srgbClr val="E77817"/>
-                </a:solidFill>
-              </a:defRPr>
-            </a:pPr>
-            <a:r>
-              <a:t>Document RAG &amp; pgvector Indexing</a:t>
+            <a:r>
+              <a:t>The 10-Agent Orchestrator Pipeline</a:t>
             </a:r>
           </a:p>
         </p:txBody>
@@ -6511,51 +5867,33 @@
           <a:bodyPr/>
           <a:lstStyle/>
           <a:p>
-            <a:pPr>
-              <a:defRPr sz="1400">
-                <a:solidFill>
-                  <a:srgbClr val="1A252C"/>
-                </a:solidFill>
-              </a:defRPr>
-            </a:pPr>
-            <a:r>
-              <a:t>Automatic Parsing: PDF, DOCX, and PPT files uploaded are automatically parsed using PDFParser.</a:t>
-            </a:r>
-          </a:p>
-          <a:p>
-            <a:pPr>
-              <a:defRPr sz="1400">
-                <a:solidFill>
-                  <a:srgbClr val="1A252C"/>
-                </a:solidFill>
-              </a:defRPr>
-            </a:pPr>
-            <a:r>
-              <a:t>Ingestion &amp; Chunking: Text is split into 600-word blocks with a 150-word overlap.</a:t>
-            </a:r>
-          </a:p>
-          <a:p>
-            <a:pPr>
-              <a:defRPr sz="1400">
-                <a:solidFill>
-                  <a:srgbClr val="1A252C"/>
-                </a:solidFill>
-              </a:defRPr>
-            </a:pPr>
-            <a:r>
-              <a:t>Embedding: Chunks are encoded into 1536-dimensional vectors.</a:t>
-            </a:r>
-          </a:p>
-          <a:p>
-            <a:pPr>
-              <a:defRPr sz="1400">
-                <a:solidFill>
-                  <a:srgbClr val="1A252C"/>
-                </a:solidFill>
-              </a:defRPr>
-            </a:pPr>
-            <a:r>
-              <a:t>Similarity Query: Uses PostgreSQL cosine distance operators supported by HNSW indexes.</a:t>
+            <a:pPr/>
+            <a:r>
+              <a:t>Planning Node: Extracts syllabus structure, units, and Course Outcomes.</a:t>
+            </a:r>
+          </a:p>
+          <a:p>
+            <a:pPr/>
+            <a:r>
+              <a:t>Generation Group (Parallel): Lesson Plan, Assignment, Quiz, and Question Paper agents.</a:t>
+            </a:r>
+          </a:p>
+          <a:p>
+            <a:pPr/>
+            <a:r>
+              <a:t>Mapping Group: Bloom Taxonomy Evaluator and Course Outcomes (CO) alignment nodes.</a:t>
+            </a:r>
+          </a:p>
+          <a:p>
+            <a:pPr/>
+            <a:r>
+              <a:t>Review Group: Consistency checker (Reviewer) and Compliance Auditor (Quality Agent).</a:t>
+            </a:r>
+          </a:p>
+          <a:p>
+            <a:pPr/>
+            <a:r>
+              <a:t>Compilation Node: Compiles raw structures into a styled ReportLab PDF pack.</a:t>
             </a:r>
           </a:p>
         </p:txBody>
@@ -6593,15 +5931,8 @@
           <a:bodyPr/>
           <a:lstStyle/>
           <a:p>
-            <a:pPr>
-              <a:defRPr b="1">
-                <a:solidFill>
-                  <a:srgbClr val="E77817"/>
-                </a:solidFill>
-              </a:defRPr>
-            </a:pPr>
-            <a:r>
-              <a:t>Geofenced QR Code Attendance</a:t>
+            <a:r>
+              <a:t>Technology Stack</a:t>
             </a:r>
           </a:p>
         </p:txBody>
@@ -6621,51 +5952,33 @@
           <a:bodyPr/>
           <a:lstStyle/>
           <a:p>
-            <a:pPr>
-              <a:defRPr sz="1400">
-                <a:solidFill>
-                  <a:srgbClr val="1A252C"/>
-                </a:solidFill>
-              </a:defRPr>
-            </a:pPr>
-            <a:r>
-              <a:t>Dynamic Time-Windows: Attendance check-in is restricted to configurable timing windows.</a:t>
-            </a:r>
-          </a:p>
-          <a:p>
-            <a:pPr>
-              <a:defRPr sz="1400">
-                <a:solidFill>
-                  <a:srgbClr val="1A252C"/>
-                </a:solidFill>
-              </a:defRPr>
-            </a:pPr>
-            <a:r>
-              <a:t>QR Token Checking: QR hashes change dynamically to prevent student code sharing.</a:t>
-            </a:r>
-          </a:p>
-          <a:p>
-            <a:pPr>
-              <a:defRPr sz="1400">
-                <a:solidFill>
-                  <a:srgbClr val="1A252C"/>
-                </a:solidFill>
-              </a:defRPr>
-            </a:pPr>
-            <a:r>
-              <a:t>GPS Geofencing: Calculates user distance against classroom coordinates (LPU block center).</a:t>
-            </a:r>
-          </a:p>
-          <a:p>
-            <a:pPr>
-              <a:defRPr sz="1400">
-                <a:solidFill>
-                  <a:srgbClr val="1A252C"/>
-                </a:solidFill>
-              </a:defRPr>
-            </a:pPr>
-            <a:r>
-              <a:t>Manual Override: HRDC staff can manually force logs, writing notes.</a:t>
+            <a:pPr/>
+            <a:r>
+              <a:t>Frontend: React 19, Next.js 15 (App Router), Framer Motion, Lucide Icons</a:t>
+            </a:r>
+          </a:p>
+          <a:p>
+            <a:pPr/>
+            <a:r>
+              <a:t>Backend: FastAPI, Uvicorn ASGI Server, SQLAlchemy ORM</a:t>
+            </a:r>
+          </a:p>
+          <a:p>
+            <a:pPr/>
+            <a:r>
+              <a:t>Database &amp; Storage: Supabase PostgreSQL (PgBouncer), Supabase Storage Buckets</a:t>
+            </a:r>
+          </a:p>
+          <a:p>
+            <a:pPr/>
+            <a:r>
+              <a:t>AI Models: Google Gemini 1.5 Flash (Primary), Groq Cloud APIs (Secondary)</a:t>
+            </a:r>
+          </a:p>
+          <a:p>
+            <a:pPr/>
+            <a:r>
+              <a:t>PDF Engine: ReportLab layout flowables</a:t>
             </a:r>
           </a:p>
         </p:txBody>

</xml_diff>